<commit_message>
Show the beta derivation and the F-beta formula on the objective slide
The slide gave the slopes and the result but not the arithmetic between
them. Now: beta^2 = slope(miss)/slope(false alarm) = 1.411/0.252 = 5.60,
beta = sqrt(5.60) = 2.37, and F_beta = (1+beta^2)PR/(beta^2 P + R).

Co-Authored-By: Claude Fable 5.1 <noreply@anthropic.com>
Claude-Session: https://claude.ai/code/session_01LW3CYoTQJimM7bQSY15feA
</commit_message>
<xml_diff>
--- a/research_project/presentation/Compositional_Temporal_Audio_Grounding_2026-09-12.pptx
+++ b/research_project/presentation/Compositional_Temporal_Audio_Grounding_2026-09-12.pptx
@@ -4657,8 +4657,8 @@
         </p:nvSpPr>
         <p:spPr>
           <a:xfrm>
-            <a:off x="713232" y="3200400"/>
-            <a:ext cx="4937760" cy="2011680"/>
+            <a:off x="713232" y="3154680"/>
+            <a:ext cx="5120640" cy="2286000"/>
           </a:xfrm>
           <a:prstGeom prst="rect">
             <a:avLst/>
@@ -4676,35 +4676,26 @@
                 <a:spcPct val="130000"/>
               </a:lnSpc>
               <a:spcAft>
-                <a:spcPts val="1000"/>
+                <a:spcPts val="700"/>
               </a:spcAft>
             </a:pPr>
             <a:r>
-              <a:rPr sz="1500" b="0">
+              <a:rPr sz="1350" b="0">
                 <a:solidFill>
                   <a:srgbClr val="2F2E2B"/>
                 </a:solidFill>
                 <a:latin typeface="Helvetica Neue"/>
               </a:rPr>
-              <a:t>from β² = 5.60, </a:t>
-            </a:r>
-            <a:r>
-              <a:rPr sz="1500" b="1">
+              <a:t>β² = slope(miss) / slope(false alarm) = 1.411 / 0.252 = </a:t>
+            </a:r>
+            <a:r>
+              <a:rPr sz="1350" b="1">
                 <a:solidFill>
                   <a:srgbClr val="0B0B0B"/>
                 </a:solidFill>
                 <a:latin typeface="Helvetica Neue"/>
               </a:rPr>
-              <a:t>read off the degradation slopes</a:t>
-            </a:r>
-            <a:r>
-              <a:rPr sz="1500" b="0">
-                <a:solidFill>
-                  <a:srgbClr val="2F2E2B"/>
-                </a:solidFill>
-                <a:latin typeface="Helvetica Neue"/>
-              </a:rPr>
-              <a:t>, not tuned.</a:t>
+              <a:t>5.60</a:t>
             </a:r>
           </a:p>
           <a:p>
@@ -4713,11 +4704,67 @@
                 <a:spcPct val="130000"/>
               </a:lnSpc>
               <a:spcAft>
-                <a:spcPts val="1000"/>
+                <a:spcPts val="700"/>
               </a:spcAft>
             </a:pPr>
             <a:r>
-              <a:rPr sz="1500" b="0">
+              <a:rPr sz="1350" b="0">
+                <a:solidFill>
+                  <a:srgbClr val="2F2E2B"/>
+                </a:solidFill>
+                <a:latin typeface="Helvetica Neue"/>
+              </a:rPr>
+              <a:t>β = √5.60 = </a:t>
+            </a:r>
+            <a:r>
+              <a:rPr sz="1350" b="1">
+                <a:solidFill>
+                  <a:srgbClr val="0B0B0B"/>
+                </a:solidFill>
+                <a:latin typeface="Helvetica Neue"/>
+              </a:rPr>
+              <a:t>2.37</a:t>
+            </a:r>
+            <a:r>
+              <a:rPr sz="1350" b="0">
+                <a:solidFill>
+                  <a:srgbClr val="2F2E2B"/>
+                </a:solidFill>
+                <a:latin typeface="Helvetica Neue"/>
+              </a:rPr>
+              <a:t>  —  read off the curves, not tuned</a:t>
+            </a:r>
+          </a:p>
+          <a:p>
+            <a:pPr>
+              <a:lnSpc>
+                <a:spcPct val="130000"/>
+              </a:lnSpc>
+              <a:spcAft>
+                <a:spcPts val="700"/>
+              </a:spcAft>
+            </a:pPr>
+            <a:r>
+              <a:rPr sz="1350" b="0">
+                <a:solidFill>
+                  <a:srgbClr val="2F2E2B"/>
+                </a:solidFill>
+                <a:latin typeface="Helvetica Neue"/>
+              </a:rPr>
+              <a:t>F_β = (1 + β²) · P · R / (β² · P + R)</a:t>
+            </a:r>
+          </a:p>
+          <a:p>
+            <a:pPr>
+              <a:lnSpc>
+                <a:spcPct val="130000"/>
+              </a:lnSpc>
+              <a:spcAft>
+                <a:spcPts val="700"/>
+              </a:spcAft>
+            </a:pPr>
+            <a:r>
+              <a:rPr sz="1350" b="0">
                 <a:solidFill>
                   <a:srgbClr val="2F2E2B"/>
                 </a:solidFill>

</xml_diff>

<commit_message>
Drop the backup results slide
The deck ends on the contributions slide; the full per-type table lives in
docs/phase1_findings.md and the speaker notes' Q&A section.

Co-Authored-By: Claude Fable 5.1 <noreply@anthropic.com>
Claude-Session: https://claude.ai/code/session_01LW3CYoTQJimM7bQSY15feA
</commit_message>
<xml_diff>
--- a/research_project/presentation/Compositional_Temporal_Audio_Grounding_2026-09-12.pptx
+++ b/research_project/presentation/Compositional_Temporal_Audio_Grounding_2026-09-12.pptx
@@ -23,7 +23,6 @@
     <p:sldId id="271" r:id="rId22"/>
     <p:sldId id="272" r:id="rId23"/>
     <p:sldId id="273" r:id="rId24"/>
-    <p:sldId id="274" r:id="rId25"/>
   </p:sldIdLst>
   <p:sldSz cx="12191695" cy="6858000" type="screen4x3"/>
   <p:notesSz cx="6858000" cy="9144000"/>
@@ -8139,2187 +8138,6 @@
           </a:graphicData>
         </a:graphic>
       </p:graphicFrame>
-    </p:spTree>
-  </p:cSld>
-  <p:clrMapOvr>
-    <a:masterClrMapping/>
-  </p:clrMapOvr>
-</p:sld>
-</file>
-
-<file path=ppt/slides/slide19.xml><?xml version="1.0" encoding="utf-8"?>
-<p:sld xmlns:a="http://schemas.openxmlformats.org/drawingml/2006/main" xmlns:p="http://schemas.openxmlformats.org/presentationml/2006/main" xmlns:r="http://schemas.openxmlformats.org/officeDocument/2006/relationships">
-  <p:cSld>
-    <p:spTree>
-      <p:nvGrpSpPr>
-        <p:cNvPr id="1" name=""/>
-        <p:cNvGrpSpPr/>
-        <p:nvPr/>
-      </p:nvGrpSpPr>
-      <p:grpSpPr/>
-      <p:sp>
-        <p:nvSpPr>
-          <p:cNvPr id="2" name="TextBox 1"/>
-          <p:cNvSpPr txBox="1"/>
-          <p:nvPr/>
-        </p:nvSpPr>
-        <p:spPr>
-          <a:xfrm>
-            <a:off x="713232" y="475488"/>
-            <a:ext cx="10765231" cy="274320"/>
-          </a:xfrm>
-          <a:prstGeom prst="rect">
-            <a:avLst/>
-          </a:prstGeom>
-          <a:noFill/>
-        </p:spPr>
-        <p:txBody>
-          <a:bodyPr wrap="none">
-            <a:spAutoFit/>
-          </a:bodyPr>
-          <a:lstStyle/>
-          <a:p>
-            <a:r>
-              <a:rPr sz="1150" b="1">
-                <a:solidFill>
-                  <a:srgbClr val="8A8880"/>
-                </a:solidFill>
-                <a:latin typeface="Helvetica Neue"/>
-              </a:rPr>
-              <a:t>APPENDIX</a:t>
-            </a:r>
-          </a:p>
-        </p:txBody>
-      </p:sp>
-      <p:sp>
-        <p:nvSpPr>
-          <p:cNvPr id="3" name="TextBox 2"/>
-          <p:cNvSpPr txBox="1"/>
-          <p:nvPr/>
-        </p:nvSpPr>
-        <p:spPr>
-          <a:xfrm>
-            <a:off x="713232" y="786384"/>
-            <a:ext cx="10765231" cy="566928"/>
-          </a:xfrm>
-          <a:prstGeom prst="rect">
-            <a:avLst/>
-          </a:prstGeom>
-          <a:noFill/>
-        </p:spPr>
-        <p:txBody>
-          <a:bodyPr wrap="none">
-            <a:spAutoFit/>
-          </a:bodyPr>
-          <a:lstStyle/>
-          <a:p>
-            <a:r>
-              <a:rPr sz="2900" b="1">
-                <a:solidFill>
-                  <a:srgbClr val="0B0B0B"/>
-                </a:solidFill>
-                <a:latin typeface="Helvetica Neue"/>
-              </a:rPr>
-              <a:t>Backup: full test-split results</a:t>
-            </a:r>
-          </a:p>
-        </p:txBody>
-      </p:sp>
-      <p:sp>
-        <p:nvSpPr>
-          <p:cNvPr id="4" name="Rectangle 3"/>
-          <p:cNvSpPr/>
-          <p:nvPr/>
-        </p:nvSpPr>
-        <p:spPr>
-          <a:xfrm>
-            <a:off x="713232" y="1408176"/>
-            <a:ext cx="960120" cy="38100"/>
-          </a:xfrm>
-          <a:prstGeom prst="rect">
-            <a:avLst/>
-          </a:prstGeom>
-          <a:solidFill>
-            <a:srgbClr val="2A78D6"/>
-          </a:solidFill>
-          <a:ln>
-            <a:noFill/>
-          </a:ln>
-          <a:effectLst/>
-        </p:spPr>
-        <p:style>
-          <a:lnRef idx="1">
-            <a:schemeClr val="accent1"/>
-          </a:lnRef>
-          <a:fillRef idx="3">
-            <a:schemeClr val="accent1"/>
-          </a:fillRef>
-          <a:effectRef idx="2">
-            <a:schemeClr val="accent1"/>
-          </a:effectRef>
-          <a:fontRef idx="minor">
-            <a:schemeClr val="lt1"/>
-          </a:fontRef>
-        </p:style>
-        <p:txBody>
-          <a:bodyPr rtlCol="0" anchor="ctr"/>
-          <a:lstStyle/>
-          <a:p>
-            <a:pPr algn="ctr"/>
-          </a:p>
-        </p:txBody>
-      </p:sp>
-      <p:sp>
-        <p:nvSpPr>
-          <p:cNvPr id="5" name="TextBox 4"/>
-          <p:cNvSpPr txBox="1"/>
-          <p:nvPr/>
-        </p:nvSpPr>
-        <p:spPr>
-          <a:xfrm>
-            <a:off x="10381183" y="6382512"/>
-            <a:ext cx="1097280" cy="274320"/>
-          </a:xfrm>
-          <a:prstGeom prst="rect">
-            <a:avLst/>
-          </a:prstGeom>
-          <a:noFill/>
-        </p:spPr>
-        <p:txBody>
-          <a:bodyPr wrap="none">
-            <a:spAutoFit/>
-          </a:bodyPr>
-          <a:lstStyle/>
-          <a:p>
-            <a:pPr algn="r"/>
-            <a:r>
-              <a:rPr sz="1000">
-                <a:solidFill>
-                  <a:srgbClr val="8A8880"/>
-                </a:solidFill>
-                <a:latin typeface="Helvetica Neue"/>
-              </a:rPr>
-              <a:t>19</a:t>
-            </a:r>
-          </a:p>
-        </p:txBody>
-      </p:sp>
-      <p:graphicFrame>
-        <p:nvGraphicFramePr>
-          <p:cNvPr id="6" name="Table 5"/>
-          <p:cNvGraphicFramePr>
-            <a:graphicFrameLocks noGrp="1"/>
-          </p:cNvGraphicFramePr>
-          <p:nvPr/>
-        </p:nvGraphicFramePr>
-        <p:xfrm>
-          <a:off x="713232" y="1965960"/>
-          <a:ext cx="10765224" cy="2651760"/>
-        </p:xfrm>
-        <a:graphic>
-          <a:graphicData uri="http://schemas.openxmlformats.org/drawingml/2006/table">
-            <a:tbl>
-              <a:tblPr firstRow="1">
-                <a:tableStyleId>{5C22544A-7EE6-4342-B048-85BDC9FD1C3A}</a:tableStyleId>
-              </a:tblPr>
-              <a:tblGrid>
-                <a:gridCol w="2372000"/>
-                <a:gridCol w="1049153"/>
-                <a:gridCol w="1049153"/>
-                <a:gridCol w="1049153"/>
-                <a:gridCol w="1049153"/>
-                <a:gridCol w="1049153"/>
-                <a:gridCol w="1049153"/>
-                <a:gridCol w="1049153"/>
-                <a:gridCol w="1049153"/>
-              </a:tblGrid>
-              <a:tr h="347472">
-                <a:tc>
-                  <a:txBody>
-                    <a:bodyPr/>
-                    <a:lstStyle/>
-                    <a:p>
-                      <a:pPr algn="l">
-                        <a:lnSpc>
-                          <a:spcPct val="112000"/>
-                        </a:lnSpc>
-                        <a:spcAft>
-                          <a:spcPts val="100"/>
-                        </a:spcAft>
-                      </a:pPr>
-                      <a:r>
-                        <a:rPr sz="1100" b="1">
-                          <a:solidFill>
-                            <a:srgbClr val="52514E"/>
-                          </a:solidFill>
-                          <a:latin typeface="Helvetica Neue"/>
-                        </a:rPr>
-                        <a:t>f1@0.5</a:t>
-                      </a:r>
-                    </a:p>
-                  </a:txBody>
-                  <a:tcPr marL="73152" marR="73152" marT="18288" marB="18288" anchor="ctr">
-                    <a:solidFill>
-                      <a:srgbClr val="F4F7FC"/>
-                    </a:solidFill>
-                  </a:tcPr>
-                </a:tc>
-                <a:tc>
-                  <a:txBody>
-                    <a:bodyPr/>
-                    <a:lstStyle/>
-                    <a:p>
-                      <a:pPr algn="ctr">
-                        <a:lnSpc>
-                          <a:spcPct val="112000"/>
-                        </a:lnSpc>
-                        <a:spcAft>
-                          <a:spcPts val="100"/>
-                        </a:spcAft>
-                      </a:pPr>
-                      <a:r>
-                        <a:rPr sz="1100" b="1">
-                          <a:solidFill>
-                            <a:srgbClr val="52514E"/>
-                          </a:solidFill>
-                          <a:latin typeface="Helvetica Neue"/>
-                        </a:rPr>
-                        <a:t>PLAIN</a:t>
-                      </a:r>
-                    </a:p>
-                  </a:txBody>
-                  <a:tcPr marL="73152" marR="73152" marT="18288" marB="18288" anchor="ctr">
-                    <a:solidFill>
-                      <a:srgbClr val="F4F7FC"/>
-                    </a:solidFill>
-                  </a:tcPr>
-                </a:tc>
-                <a:tc>
-                  <a:txBody>
-                    <a:bodyPr/>
-                    <a:lstStyle/>
-                    <a:p>
-                      <a:pPr algn="ctr">
-                        <a:lnSpc>
-                          <a:spcPct val="112000"/>
-                        </a:lnSpc>
-                        <a:spcAft>
-                          <a:spcPts val="100"/>
-                        </a:spcAft>
-                      </a:pPr>
-                      <a:r>
-                        <a:rPr sz="1100" b="1">
-                          <a:solidFill>
-                            <a:srgbClr val="52514E"/>
-                          </a:solidFill>
-                          <a:latin typeface="Helvetica Neue"/>
-                        </a:rPr>
-                        <a:t>ORDINAL</a:t>
-                      </a:r>
-                    </a:p>
-                  </a:txBody>
-                  <a:tcPr marL="73152" marR="73152" marT="18288" marB="18288" anchor="ctr">
-                    <a:solidFill>
-                      <a:srgbClr val="F4F7FC"/>
-                    </a:solidFill>
-                  </a:tcPr>
-                </a:tc>
-                <a:tc>
-                  <a:txBody>
-                    <a:bodyPr/>
-                    <a:lstStyle/>
-                    <a:p>
-                      <a:pPr algn="ctr">
-                        <a:lnSpc>
-                          <a:spcPct val="112000"/>
-                        </a:lnSpc>
-                        <a:spcAft>
-                          <a:spcPts val="100"/>
-                        </a:spcAft>
-                      </a:pPr>
-                      <a:r>
-                        <a:rPr sz="1100" b="1">
-                          <a:solidFill>
-                            <a:srgbClr val="52514E"/>
-                          </a:solidFill>
-                          <a:latin typeface="Helvetica Neue"/>
-                        </a:rPr>
-                        <a:t>AFTER</a:t>
-                      </a:r>
-                    </a:p>
-                  </a:txBody>
-                  <a:tcPr marL="73152" marR="73152" marT="18288" marB="18288" anchor="ctr">
-                    <a:solidFill>
-                      <a:srgbClr val="F4F7FC"/>
-                    </a:solidFill>
-                  </a:tcPr>
-                </a:tc>
-                <a:tc>
-                  <a:txBody>
-                    <a:bodyPr/>
-                    <a:lstStyle/>
-                    <a:p>
-                      <a:pPr algn="ctr">
-                        <a:lnSpc>
-                          <a:spcPct val="112000"/>
-                        </a:lnSpc>
-                        <a:spcAft>
-                          <a:spcPts val="100"/>
-                        </a:spcAft>
-                      </a:pPr>
-                      <a:r>
-                        <a:rPr sz="1100" b="1">
-                          <a:solidFill>
-                            <a:srgbClr val="52514E"/>
-                          </a:solidFill>
-                          <a:latin typeface="Helvetica Neue"/>
-                        </a:rPr>
-                        <a:t>BEFORE</a:t>
-                      </a:r>
-                    </a:p>
-                  </a:txBody>
-                  <a:tcPr marL="73152" marR="73152" marT="18288" marB="18288" anchor="ctr">
-                    <a:solidFill>
-                      <a:srgbClr val="F4F7FC"/>
-                    </a:solidFill>
-                  </a:tcPr>
-                </a:tc>
-                <a:tc>
-                  <a:txBody>
-                    <a:bodyPr/>
-                    <a:lstStyle/>
-                    <a:p>
-                      <a:pPr algn="ctr">
-                        <a:lnSpc>
-                          <a:spcPct val="112000"/>
-                        </a:lnSpc>
-                        <a:spcAft>
-                          <a:spcPts val="100"/>
-                        </a:spcAft>
-                      </a:pPr>
-                      <a:r>
-                        <a:rPr sz="1100" b="1">
-                          <a:solidFill>
-                            <a:srgbClr val="52514E"/>
-                          </a:solidFill>
-                          <a:latin typeface="Helvetica Neue"/>
-                        </a:rPr>
-                        <a:t>NEXT_AFTER</a:t>
-                      </a:r>
-                    </a:p>
-                  </a:txBody>
-                  <a:tcPr marL="73152" marR="73152" marT="18288" marB="18288" anchor="ctr">
-                    <a:solidFill>
-                      <a:srgbClr val="F4F7FC"/>
-                    </a:solidFill>
-                  </a:tcPr>
-                </a:tc>
-                <a:tc>
-                  <a:txBody>
-                    <a:bodyPr/>
-                    <a:lstStyle/>
-                    <a:p>
-                      <a:pPr algn="ctr">
-                        <a:lnSpc>
-                          <a:spcPct val="112000"/>
-                        </a:lnSpc>
-                        <a:spcAft>
-                          <a:spcPts val="100"/>
-                        </a:spcAft>
-                      </a:pPr>
-                      <a:r>
-                        <a:rPr sz="1100" b="1">
-                          <a:solidFill>
-                            <a:srgbClr val="52514E"/>
-                          </a:solidFill>
-                          <a:latin typeface="Helvetica Neue"/>
-                        </a:rPr>
-                        <a:t>WHILE</a:t>
-                      </a:r>
-                    </a:p>
-                  </a:txBody>
-                  <a:tcPr marL="73152" marR="73152" marT="18288" marB="18288" anchor="ctr">
-                    <a:solidFill>
-                      <a:srgbClr val="F4F7FC"/>
-                    </a:solidFill>
-                  </a:tcPr>
-                </a:tc>
-                <a:tc>
-                  <a:txBody>
-                    <a:bodyPr/>
-                    <a:lstStyle/>
-                    <a:p>
-                      <a:pPr algn="ctr">
-                        <a:lnSpc>
-                          <a:spcPct val="112000"/>
-                        </a:lnSpc>
-                        <a:spcAft>
-                          <a:spcPts val="100"/>
-                        </a:spcAft>
-                      </a:pPr>
-                      <a:r>
-                        <a:rPr sz="1100" b="1">
-                          <a:solidFill>
-                            <a:srgbClr val="52514E"/>
-                          </a:solidFill>
-                          <a:latin typeface="Helvetica Neue"/>
-                        </a:rPr>
-                        <a:t>NOT_FOLL.</a:t>
-                      </a:r>
-                    </a:p>
-                  </a:txBody>
-                  <a:tcPr marL="73152" marR="73152" marT="18288" marB="18288" anchor="ctr">
-                    <a:solidFill>
-                      <a:srgbClr val="F4F7FC"/>
-                    </a:solidFill>
-                  </a:tcPr>
-                </a:tc>
-                <a:tc>
-                  <a:txBody>
-                    <a:bodyPr/>
-                    <a:lstStyle/>
-                    <a:p>
-                      <a:pPr algn="ctr">
-                        <a:lnSpc>
-                          <a:spcPct val="112000"/>
-                        </a:lnSpc>
-                        <a:spcAft>
-                          <a:spcPts val="100"/>
-                        </a:spcAft>
-                      </a:pPr>
-                      <a:r>
-                        <a:rPr sz="1100" b="1">
-                          <a:solidFill>
-                            <a:srgbClr val="52514E"/>
-                          </a:solidFill>
-                          <a:latin typeface="Helvetica Neue"/>
-                        </a:rPr>
-                        <a:t>ALL</a:t>
-                      </a:r>
-                    </a:p>
-                  </a:txBody>
-                  <a:tcPr marL="73152" marR="73152" marT="18288" marB="18288" anchor="ctr">
-                    <a:solidFill>
-                      <a:srgbClr val="F4F7FC"/>
-                    </a:solidFill>
-                  </a:tcPr>
-                </a:tc>
-              </a:tr>
-              <a:tr h="384048">
-                <a:tc>
-                  <a:txBody>
-                    <a:bodyPr/>
-                    <a:lstStyle/>
-                    <a:p>
-                      <a:pPr algn="l">
-                        <a:lnSpc>
-                          <a:spcPct val="112000"/>
-                        </a:lnSpc>
-                        <a:spcAft>
-                          <a:spcPts val="100"/>
-                        </a:spcAft>
-                      </a:pPr>
-                      <a:r>
-                        <a:rPr sz="1150" b="0">
-                          <a:solidFill>
-                            <a:srgbClr val="2F2E2B"/>
-                          </a:solidFill>
-                          <a:latin typeface="Helvetica Neue"/>
-                        </a:rPr>
-                        <a:t>A  direct</a:t>
-                      </a:r>
-                    </a:p>
-                  </a:txBody>
-                  <a:tcPr marL="73152" marR="73152" marT="18288" marB="18288" anchor="ctr">
-                    <a:solidFill>
-                      <a:srgbClr val="FFFFFF"/>
-                    </a:solidFill>
-                  </a:tcPr>
-                </a:tc>
-                <a:tc>
-                  <a:txBody>
-                    <a:bodyPr/>
-                    <a:lstStyle/>
-                    <a:p>
-                      <a:pPr algn="ctr">
-                        <a:lnSpc>
-                          <a:spcPct val="112000"/>
-                        </a:lnSpc>
-                        <a:spcAft>
-                          <a:spcPts val="100"/>
-                        </a:spcAft>
-                      </a:pPr>
-                      <a:r>
-                        <a:rPr sz="1150" b="0">
-                          <a:solidFill>
-                            <a:srgbClr val="2F2E2B"/>
-                          </a:solidFill>
-                          <a:latin typeface="Helvetica Neue"/>
-                        </a:rPr>
-                        <a:t>0.276</a:t>
-                      </a:r>
-                    </a:p>
-                  </a:txBody>
-                  <a:tcPr marL="73152" marR="73152" marT="18288" marB="18288" anchor="ctr">
-                    <a:solidFill>
-                      <a:srgbClr val="FFFFFF"/>
-                    </a:solidFill>
-                  </a:tcPr>
-                </a:tc>
-                <a:tc>
-                  <a:txBody>
-                    <a:bodyPr/>
-                    <a:lstStyle/>
-                    <a:p>
-                      <a:pPr algn="ctr">
-                        <a:lnSpc>
-                          <a:spcPct val="112000"/>
-                        </a:lnSpc>
-                        <a:spcAft>
-                          <a:spcPts val="100"/>
-                        </a:spcAft>
-                      </a:pPr>
-                      <a:r>
-                        <a:rPr sz="1150" b="0">
-                          <a:solidFill>
-                            <a:srgbClr val="2F2E2B"/>
-                          </a:solidFill>
-                          <a:latin typeface="Helvetica Neue"/>
-                        </a:rPr>
-                        <a:t>0.188</a:t>
-                      </a:r>
-                    </a:p>
-                  </a:txBody>
-                  <a:tcPr marL="73152" marR="73152" marT="18288" marB="18288" anchor="ctr">
-                    <a:solidFill>
-                      <a:srgbClr val="FFFFFF"/>
-                    </a:solidFill>
-                  </a:tcPr>
-                </a:tc>
-                <a:tc>
-                  <a:txBody>
-                    <a:bodyPr/>
-                    <a:lstStyle/>
-                    <a:p>
-                      <a:pPr algn="ctr">
-                        <a:lnSpc>
-                          <a:spcPct val="112000"/>
-                        </a:lnSpc>
-                        <a:spcAft>
-                          <a:spcPts val="100"/>
-                        </a:spcAft>
-                      </a:pPr>
-                      <a:r>
-                        <a:rPr sz="1150" b="0">
-                          <a:solidFill>
-                            <a:srgbClr val="2F2E2B"/>
-                          </a:solidFill>
-                          <a:latin typeface="Helvetica Neue"/>
-                        </a:rPr>
-                        <a:t>0.220</a:t>
-                      </a:r>
-                    </a:p>
-                  </a:txBody>
-                  <a:tcPr marL="73152" marR="73152" marT="18288" marB="18288" anchor="ctr">
-                    <a:solidFill>
-                      <a:srgbClr val="FFFFFF"/>
-                    </a:solidFill>
-                  </a:tcPr>
-                </a:tc>
-                <a:tc>
-                  <a:txBody>
-                    <a:bodyPr/>
-                    <a:lstStyle/>
-                    <a:p>
-                      <a:pPr algn="ctr">
-                        <a:lnSpc>
-                          <a:spcPct val="112000"/>
-                        </a:lnSpc>
-                        <a:spcAft>
-                          <a:spcPts val="100"/>
-                        </a:spcAft>
-                      </a:pPr>
-                      <a:r>
-                        <a:rPr sz="1150" b="0">
-                          <a:solidFill>
-                            <a:srgbClr val="2F2E2B"/>
-                          </a:solidFill>
-                          <a:latin typeface="Helvetica Neue"/>
-                        </a:rPr>
-                        <a:t>0.323</a:t>
-                      </a:r>
-                    </a:p>
-                  </a:txBody>
-                  <a:tcPr marL="73152" marR="73152" marT="18288" marB="18288" anchor="ctr">
-                    <a:solidFill>
-                      <a:srgbClr val="FFFFFF"/>
-                    </a:solidFill>
-                  </a:tcPr>
-                </a:tc>
-                <a:tc>
-                  <a:txBody>
-                    <a:bodyPr/>
-                    <a:lstStyle/>
-                    <a:p>
-                      <a:pPr algn="ctr">
-                        <a:lnSpc>
-                          <a:spcPct val="112000"/>
-                        </a:lnSpc>
-                        <a:spcAft>
-                          <a:spcPts val="100"/>
-                        </a:spcAft>
-                      </a:pPr>
-                      <a:r>
-                        <a:rPr sz="1150" b="0">
-                          <a:solidFill>
-                            <a:srgbClr val="2F2E2B"/>
-                          </a:solidFill>
-                          <a:latin typeface="Helvetica Neue"/>
-                        </a:rPr>
-                        <a:t>0.101</a:t>
-                      </a:r>
-                    </a:p>
-                  </a:txBody>
-                  <a:tcPr marL="73152" marR="73152" marT="18288" marB="18288" anchor="ctr">
-                    <a:solidFill>
-                      <a:srgbClr val="FFFFFF"/>
-                    </a:solidFill>
-                  </a:tcPr>
-                </a:tc>
-                <a:tc>
-                  <a:txBody>
-                    <a:bodyPr/>
-                    <a:lstStyle/>
-                    <a:p>
-                      <a:pPr algn="ctr">
-                        <a:lnSpc>
-                          <a:spcPct val="112000"/>
-                        </a:lnSpc>
-                        <a:spcAft>
-                          <a:spcPts val="100"/>
-                        </a:spcAft>
-                      </a:pPr>
-                      <a:r>
-                        <a:rPr sz="1150" b="0">
-                          <a:solidFill>
-                            <a:srgbClr val="2F2E2B"/>
-                          </a:solidFill>
-                          <a:latin typeface="Helvetica Neue"/>
-                        </a:rPr>
-                        <a:t>0.175</a:t>
-                      </a:r>
-                    </a:p>
-                  </a:txBody>
-                  <a:tcPr marL="73152" marR="73152" marT="18288" marB="18288" anchor="ctr">
-                    <a:solidFill>
-                      <a:srgbClr val="FFFFFF"/>
-                    </a:solidFill>
-                  </a:tcPr>
-                </a:tc>
-                <a:tc>
-                  <a:txBody>
-                    <a:bodyPr/>
-                    <a:lstStyle/>
-                    <a:p>
-                      <a:pPr algn="ctr">
-                        <a:lnSpc>
-                          <a:spcPct val="112000"/>
-                        </a:lnSpc>
-                        <a:spcAft>
-                          <a:spcPts val="100"/>
-                        </a:spcAft>
-                      </a:pPr>
-                      <a:r>
-                        <a:rPr sz="1150" b="0">
-                          <a:solidFill>
-                            <a:srgbClr val="2F2E2B"/>
-                          </a:solidFill>
-                          <a:latin typeface="Helvetica Neue"/>
-                        </a:rPr>
-                        <a:t>0.146</a:t>
-                      </a:r>
-                    </a:p>
-                  </a:txBody>
-                  <a:tcPr marL="73152" marR="73152" marT="18288" marB="18288" anchor="ctr">
-                    <a:solidFill>
-                      <a:srgbClr val="FFFFFF"/>
-                    </a:solidFill>
-                  </a:tcPr>
-                </a:tc>
-                <a:tc>
-                  <a:txBody>
-                    <a:bodyPr/>
-                    <a:lstStyle/>
-                    <a:p>
-                      <a:pPr algn="ctr">
-                        <a:lnSpc>
-                          <a:spcPct val="112000"/>
-                        </a:lnSpc>
-                        <a:spcAft>
-                          <a:spcPts val="100"/>
-                        </a:spcAft>
-                      </a:pPr>
-                      <a:r>
-                        <a:rPr sz="1150" b="0">
-                          <a:solidFill>
-                            <a:srgbClr val="2F2E2B"/>
-                          </a:solidFill>
-                          <a:latin typeface="Helvetica Neue"/>
-                        </a:rPr>
-                        <a:t>0.207</a:t>
-                      </a:r>
-                    </a:p>
-                  </a:txBody>
-                  <a:tcPr marL="73152" marR="73152" marT="18288" marB="18288" anchor="ctr">
-                    <a:solidFill>
-                      <a:srgbClr val="FFFFFF"/>
-                    </a:solidFill>
-                  </a:tcPr>
-                </a:tc>
-              </a:tr>
-              <a:tr h="384048">
-                <a:tc>
-                  <a:txBody>
-                    <a:bodyPr/>
-                    <a:lstStyle/>
-                    <a:p>
-                      <a:pPr algn="l">
-                        <a:lnSpc>
-                          <a:spcPct val="112000"/>
-                        </a:lnSpc>
-                        <a:spcAft>
-                          <a:spcPts val="100"/>
-                        </a:spcAft>
-                      </a:pPr>
-                      <a:r>
-                        <a:rPr sz="1150" b="0">
-                          <a:solidFill>
-                            <a:srgbClr val="2F2E2B"/>
-                          </a:solidFill>
-                          <a:latin typeface="Helvetica Neue"/>
-                        </a:rPr>
-                        <a:t>B  decompose</a:t>
-                      </a:r>
-                    </a:p>
-                  </a:txBody>
-                  <a:tcPr marL="73152" marR="73152" marT="18288" marB="18288" anchor="ctr">
-                    <a:solidFill>
-                      <a:srgbClr val="FFFFFF"/>
-                    </a:solidFill>
-                  </a:tcPr>
-                </a:tc>
-                <a:tc>
-                  <a:txBody>
-                    <a:bodyPr/>
-                    <a:lstStyle/>
-                    <a:p>
-                      <a:pPr algn="ctr">
-                        <a:lnSpc>
-                          <a:spcPct val="112000"/>
-                        </a:lnSpc>
-                        <a:spcAft>
-                          <a:spcPts val="100"/>
-                        </a:spcAft>
-                      </a:pPr>
-                      <a:r>
-                        <a:rPr sz="1150" b="0">
-                          <a:solidFill>
-                            <a:srgbClr val="2F2E2B"/>
-                          </a:solidFill>
-                          <a:latin typeface="Helvetica Neue"/>
-                        </a:rPr>
-                        <a:t>0.295</a:t>
-                      </a:r>
-                    </a:p>
-                  </a:txBody>
-                  <a:tcPr marL="73152" marR="73152" marT="18288" marB="18288" anchor="ctr">
-                    <a:solidFill>
-                      <a:srgbClr val="FFFFFF"/>
-                    </a:solidFill>
-                  </a:tcPr>
-                </a:tc>
-                <a:tc>
-                  <a:txBody>
-                    <a:bodyPr/>
-                    <a:lstStyle/>
-                    <a:p>
-                      <a:pPr algn="ctr">
-                        <a:lnSpc>
-                          <a:spcPct val="112000"/>
-                        </a:lnSpc>
-                        <a:spcAft>
-                          <a:spcPts val="100"/>
-                        </a:spcAft>
-                      </a:pPr>
-                      <a:r>
-                        <a:rPr sz="1150" b="0">
-                          <a:solidFill>
-                            <a:srgbClr val="2F2E2B"/>
-                          </a:solidFill>
-                          <a:latin typeface="Helvetica Neue"/>
-                        </a:rPr>
-                        <a:t>0.212</a:t>
-                      </a:r>
-                    </a:p>
-                  </a:txBody>
-                  <a:tcPr marL="73152" marR="73152" marT="18288" marB="18288" anchor="ctr">
-                    <a:solidFill>
-                      <a:srgbClr val="FFFFFF"/>
-                    </a:solidFill>
-                  </a:tcPr>
-                </a:tc>
-                <a:tc>
-                  <a:txBody>
-                    <a:bodyPr/>
-                    <a:lstStyle/>
-                    <a:p>
-                      <a:pPr algn="ctr">
-                        <a:lnSpc>
-                          <a:spcPct val="112000"/>
-                        </a:lnSpc>
-                        <a:spcAft>
-                          <a:spcPts val="100"/>
-                        </a:spcAft>
-                      </a:pPr>
-                      <a:r>
-                        <a:rPr sz="1150" b="0">
-                          <a:solidFill>
-                            <a:srgbClr val="2F2E2B"/>
-                          </a:solidFill>
-                          <a:latin typeface="Helvetica Neue"/>
-                        </a:rPr>
-                        <a:t>0.234</a:t>
-                      </a:r>
-                    </a:p>
-                  </a:txBody>
-                  <a:tcPr marL="73152" marR="73152" marT="18288" marB="18288" anchor="ctr">
-                    <a:solidFill>
-                      <a:srgbClr val="FFFFFF"/>
-                    </a:solidFill>
-                  </a:tcPr>
-                </a:tc>
-                <a:tc>
-                  <a:txBody>
-                    <a:bodyPr/>
-                    <a:lstStyle/>
-                    <a:p>
-                      <a:pPr algn="ctr">
-                        <a:lnSpc>
-                          <a:spcPct val="112000"/>
-                        </a:lnSpc>
-                        <a:spcAft>
-                          <a:spcPts val="100"/>
-                        </a:spcAft>
-                      </a:pPr>
-                      <a:r>
-                        <a:rPr sz="1150" b="0">
-                          <a:solidFill>
-                            <a:srgbClr val="2F2E2B"/>
-                          </a:solidFill>
-                          <a:latin typeface="Helvetica Neue"/>
-                        </a:rPr>
-                        <a:t>0.228</a:t>
-                      </a:r>
-                    </a:p>
-                  </a:txBody>
-                  <a:tcPr marL="73152" marR="73152" marT="18288" marB="18288" anchor="ctr">
-                    <a:solidFill>
-                      <a:srgbClr val="FFFFFF"/>
-                    </a:solidFill>
-                  </a:tcPr>
-                </a:tc>
-                <a:tc>
-                  <a:txBody>
-                    <a:bodyPr/>
-                    <a:lstStyle/>
-                    <a:p>
-                      <a:pPr algn="ctr">
-                        <a:lnSpc>
-                          <a:spcPct val="112000"/>
-                        </a:lnSpc>
-                        <a:spcAft>
-                          <a:spcPts val="100"/>
-                        </a:spcAft>
-                      </a:pPr>
-                      <a:r>
-                        <a:rPr sz="1150" b="0">
-                          <a:solidFill>
-                            <a:srgbClr val="2F2E2B"/>
-                          </a:solidFill>
-                          <a:latin typeface="Helvetica Neue"/>
-                        </a:rPr>
-                        <a:t>0.159</a:t>
-                      </a:r>
-                    </a:p>
-                  </a:txBody>
-                  <a:tcPr marL="73152" marR="73152" marT="18288" marB="18288" anchor="ctr">
-                    <a:solidFill>
-                      <a:srgbClr val="FFFFFF"/>
-                    </a:solidFill>
-                  </a:tcPr>
-                </a:tc>
-                <a:tc>
-                  <a:txBody>
-                    <a:bodyPr/>
-                    <a:lstStyle/>
-                    <a:p>
-                      <a:pPr algn="ctr">
-                        <a:lnSpc>
-                          <a:spcPct val="112000"/>
-                        </a:lnSpc>
-                        <a:spcAft>
-                          <a:spcPts val="100"/>
-                        </a:spcAft>
-                      </a:pPr>
-                      <a:r>
-                        <a:rPr sz="1150" b="0">
-                          <a:solidFill>
-                            <a:srgbClr val="2F2E2B"/>
-                          </a:solidFill>
-                          <a:latin typeface="Helvetica Neue"/>
-                        </a:rPr>
-                        <a:t>0.146</a:t>
-                      </a:r>
-                    </a:p>
-                  </a:txBody>
-                  <a:tcPr marL="73152" marR="73152" marT="18288" marB="18288" anchor="ctr">
-                    <a:solidFill>
-                      <a:srgbClr val="FFFFFF"/>
-                    </a:solidFill>
-                  </a:tcPr>
-                </a:tc>
-                <a:tc>
-                  <a:txBody>
-                    <a:bodyPr/>
-                    <a:lstStyle/>
-                    <a:p>
-                      <a:pPr algn="ctr">
-                        <a:lnSpc>
-                          <a:spcPct val="112000"/>
-                        </a:lnSpc>
-                        <a:spcAft>
-                          <a:spcPts val="100"/>
-                        </a:spcAft>
-                      </a:pPr>
-                      <a:r>
-                        <a:rPr sz="1150" b="0">
-                          <a:solidFill>
-                            <a:srgbClr val="2F2E2B"/>
-                          </a:solidFill>
-                          <a:latin typeface="Helvetica Neue"/>
-                        </a:rPr>
-                        <a:t>0.215</a:t>
-                      </a:r>
-                    </a:p>
-                  </a:txBody>
-                  <a:tcPr marL="73152" marR="73152" marT="18288" marB="18288" anchor="ctr">
-                    <a:solidFill>
-                      <a:srgbClr val="FFFFFF"/>
-                    </a:solidFill>
-                  </a:tcPr>
-                </a:tc>
-                <a:tc>
-                  <a:txBody>
-                    <a:bodyPr/>
-                    <a:lstStyle/>
-                    <a:p>
-                      <a:pPr algn="ctr">
-                        <a:lnSpc>
-                          <a:spcPct val="112000"/>
-                        </a:lnSpc>
-                        <a:spcAft>
-                          <a:spcPts val="100"/>
-                        </a:spcAft>
-                      </a:pPr>
-                      <a:r>
-                        <a:rPr sz="1150" b="0">
-                          <a:solidFill>
-                            <a:srgbClr val="2F2E2B"/>
-                          </a:solidFill>
-                          <a:latin typeface="Helvetica Neue"/>
-                        </a:rPr>
-                        <a:t>0.218</a:t>
-                      </a:r>
-                    </a:p>
-                  </a:txBody>
-                  <a:tcPr marL="73152" marR="73152" marT="18288" marB="18288" anchor="ctr">
-                    <a:solidFill>
-                      <a:srgbClr val="FFFFFF"/>
-                    </a:solidFill>
-                  </a:tcPr>
-                </a:tc>
-              </a:tr>
-              <a:tr h="384048">
-                <a:tc>
-                  <a:txBody>
-                    <a:bodyPr/>
-                    <a:lstStyle/>
-                    <a:p>
-                      <a:pPr algn="l">
-                        <a:lnSpc>
-                          <a:spcPct val="112000"/>
-                        </a:lnSpc>
-                        <a:spcAft>
-                          <a:spcPts val="100"/>
-                        </a:spcAft>
-                      </a:pPr>
-                      <a:r>
-                        <a:rPr sz="1150" b="0">
-                          <a:solidFill>
-                            <a:srgbClr val="2F2E2B"/>
-                          </a:solidFill>
-                          <a:latin typeface="Helvetica Neue"/>
-                        </a:rPr>
-                        <a:t>Vote-and-merge</a:t>
-                      </a:r>
-                    </a:p>
-                  </a:txBody>
-                  <a:tcPr marL="73152" marR="73152" marT="18288" marB="18288" anchor="ctr">
-                    <a:solidFill>
-                      <a:srgbClr val="FFFFFF"/>
-                    </a:solidFill>
-                  </a:tcPr>
-                </a:tc>
-                <a:tc>
-                  <a:txBody>
-                    <a:bodyPr/>
-                    <a:lstStyle/>
-                    <a:p>
-                      <a:pPr algn="ctr">
-                        <a:lnSpc>
-                          <a:spcPct val="112000"/>
-                        </a:lnSpc>
-                        <a:spcAft>
-                          <a:spcPts val="100"/>
-                        </a:spcAft>
-                      </a:pPr>
-                      <a:r>
-                        <a:rPr sz="1150" b="0">
-                          <a:solidFill>
-                            <a:srgbClr val="2F2E2B"/>
-                          </a:solidFill>
-                          <a:latin typeface="Helvetica Neue"/>
-                        </a:rPr>
-                        <a:t>0.254</a:t>
-                      </a:r>
-                    </a:p>
-                  </a:txBody>
-                  <a:tcPr marL="73152" marR="73152" marT="18288" marB="18288" anchor="ctr">
-                    <a:solidFill>
-                      <a:srgbClr val="FFFFFF"/>
-                    </a:solidFill>
-                  </a:tcPr>
-                </a:tc>
-                <a:tc>
-                  <a:txBody>
-                    <a:bodyPr/>
-                    <a:lstStyle/>
-                    <a:p>
-                      <a:pPr algn="ctr">
-                        <a:lnSpc>
-                          <a:spcPct val="112000"/>
-                        </a:lnSpc>
-                        <a:spcAft>
-                          <a:spcPts val="100"/>
-                        </a:spcAft>
-                      </a:pPr>
-                      <a:r>
-                        <a:rPr sz="1150" b="0">
-                          <a:solidFill>
-                            <a:srgbClr val="2F2E2B"/>
-                          </a:solidFill>
-                          <a:latin typeface="Helvetica Neue"/>
-                        </a:rPr>
-                        <a:t>0.079</a:t>
-                      </a:r>
-                    </a:p>
-                  </a:txBody>
-                  <a:tcPr marL="73152" marR="73152" marT="18288" marB="18288" anchor="ctr">
-                    <a:solidFill>
-                      <a:srgbClr val="FFFFFF"/>
-                    </a:solidFill>
-                  </a:tcPr>
-                </a:tc>
-                <a:tc>
-                  <a:txBody>
-                    <a:bodyPr/>
-                    <a:lstStyle/>
-                    <a:p>
-                      <a:pPr algn="ctr">
-                        <a:lnSpc>
-                          <a:spcPct val="112000"/>
-                        </a:lnSpc>
-                        <a:spcAft>
-                          <a:spcPts val="100"/>
-                        </a:spcAft>
-                      </a:pPr>
-                      <a:r>
-                        <a:rPr sz="1150" b="0">
-                          <a:solidFill>
-                            <a:srgbClr val="2F2E2B"/>
-                          </a:solidFill>
-                          <a:latin typeface="Helvetica Neue"/>
-                        </a:rPr>
-                        <a:t>0.117</a:t>
-                      </a:r>
-                    </a:p>
-                  </a:txBody>
-                  <a:tcPr marL="73152" marR="73152" marT="18288" marB="18288" anchor="ctr">
-                    <a:solidFill>
-                      <a:srgbClr val="FFFFFF"/>
-                    </a:solidFill>
-                  </a:tcPr>
-                </a:tc>
-                <a:tc>
-                  <a:txBody>
-                    <a:bodyPr/>
-                    <a:lstStyle/>
-                    <a:p>
-                      <a:pPr algn="ctr">
-                        <a:lnSpc>
-                          <a:spcPct val="112000"/>
-                        </a:lnSpc>
-                        <a:spcAft>
-                          <a:spcPts val="100"/>
-                        </a:spcAft>
-                      </a:pPr>
-                      <a:r>
-                        <a:rPr sz="1150" b="0">
-                          <a:solidFill>
-                            <a:srgbClr val="2F2E2B"/>
-                          </a:solidFill>
-                          <a:latin typeface="Helvetica Neue"/>
-                        </a:rPr>
-                        <a:t>0.330</a:t>
-                      </a:r>
-                    </a:p>
-                  </a:txBody>
-                  <a:tcPr marL="73152" marR="73152" marT="18288" marB="18288" anchor="ctr">
-                    <a:solidFill>
-                      <a:srgbClr val="FFFFFF"/>
-                    </a:solidFill>
-                  </a:tcPr>
-                </a:tc>
-                <a:tc>
-                  <a:txBody>
-                    <a:bodyPr/>
-                    <a:lstStyle/>
-                    <a:p>
-                      <a:pPr algn="ctr">
-                        <a:lnSpc>
-                          <a:spcPct val="112000"/>
-                        </a:lnSpc>
-                        <a:spcAft>
-                          <a:spcPts val="100"/>
-                        </a:spcAft>
-                      </a:pPr>
-                      <a:r>
-                        <a:rPr sz="1150" b="0">
-                          <a:solidFill>
-                            <a:srgbClr val="2F2E2B"/>
-                          </a:solidFill>
-                          <a:latin typeface="Helvetica Neue"/>
-                        </a:rPr>
-                        <a:t>0.063</a:t>
-                      </a:r>
-                    </a:p>
-                  </a:txBody>
-                  <a:tcPr marL="73152" marR="73152" marT="18288" marB="18288" anchor="ctr">
-                    <a:solidFill>
-                      <a:srgbClr val="FFFFFF"/>
-                    </a:solidFill>
-                  </a:tcPr>
-                </a:tc>
-                <a:tc>
-                  <a:txBody>
-                    <a:bodyPr/>
-                    <a:lstStyle/>
-                    <a:p>
-                      <a:pPr algn="ctr">
-                        <a:lnSpc>
-                          <a:spcPct val="112000"/>
-                        </a:lnSpc>
-                        <a:spcAft>
-                          <a:spcPts val="100"/>
-                        </a:spcAft>
-                      </a:pPr>
-                      <a:r>
-                        <a:rPr sz="1150" b="0">
-                          <a:solidFill>
-                            <a:srgbClr val="2F2E2B"/>
-                          </a:solidFill>
-                          <a:latin typeface="Helvetica Neue"/>
-                        </a:rPr>
-                        <a:t>0.100</a:t>
-                      </a:r>
-                    </a:p>
-                  </a:txBody>
-                  <a:tcPr marL="73152" marR="73152" marT="18288" marB="18288" anchor="ctr">
-                    <a:solidFill>
-                      <a:srgbClr val="FFFFFF"/>
-                    </a:solidFill>
-                  </a:tcPr>
-                </a:tc>
-                <a:tc>
-                  <a:txBody>
-                    <a:bodyPr/>
-                    <a:lstStyle/>
-                    <a:p>
-                      <a:pPr algn="ctr">
-                        <a:lnSpc>
-                          <a:spcPct val="112000"/>
-                        </a:lnSpc>
-                        <a:spcAft>
-                          <a:spcPts val="100"/>
-                        </a:spcAft>
-                      </a:pPr>
-                      <a:r>
-                        <a:rPr sz="1150" b="0">
-                          <a:solidFill>
-                            <a:srgbClr val="2F2E2B"/>
-                          </a:solidFill>
-                          <a:latin typeface="Helvetica Neue"/>
-                        </a:rPr>
-                        <a:t>0.083</a:t>
-                      </a:r>
-                    </a:p>
-                  </a:txBody>
-                  <a:tcPr marL="73152" marR="73152" marT="18288" marB="18288" anchor="ctr">
-                    <a:solidFill>
-                      <a:srgbClr val="FFFFFF"/>
-                    </a:solidFill>
-                  </a:tcPr>
-                </a:tc>
-                <a:tc>
-                  <a:txBody>
-                    <a:bodyPr/>
-                    <a:lstStyle/>
-                    <a:p>
-                      <a:pPr algn="ctr">
-                        <a:lnSpc>
-                          <a:spcPct val="112000"/>
-                        </a:lnSpc>
-                        <a:spcAft>
-                          <a:spcPts val="100"/>
-                        </a:spcAft>
-                      </a:pPr>
-                      <a:r>
-                        <a:rPr sz="1150" b="0">
-                          <a:solidFill>
-                            <a:srgbClr val="2F2E2B"/>
-                          </a:solidFill>
-                          <a:latin typeface="Helvetica Neue"/>
-                        </a:rPr>
-                        <a:t>0.150</a:t>
-                      </a:r>
-                    </a:p>
-                  </a:txBody>
-                  <a:tcPr marL="73152" marR="73152" marT="18288" marB="18288" anchor="ctr">
-                    <a:solidFill>
-                      <a:srgbClr val="FFFFFF"/>
-                    </a:solidFill>
-                  </a:tcPr>
-                </a:tc>
-              </a:tr>
-              <a:tr h="384048">
-                <a:tc>
-                  <a:txBody>
-                    <a:bodyPr/>
-                    <a:lstStyle/>
-                    <a:p>
-                      <a:pPr algn="l">
-                        <a:lnSpc>
-                          <a:spcPct val="112000"/>
-                        </a:lnSpc>
-                        <a:spcAft>
-                          <a:spcPts val="100"/>
-                        </a:spcAft>
-                      </a:pPr>
-                      <a:r>
-                        <a:rPr sz="1150" b="0">
-                          <a:solidFill>
-                            <a:srgbClr val="2F2E2B"/>
-                          </a:solidFill>
-                          <a:latin typeface="Helvetica Neue"/>
-                        </a:rPr>
-                        <a:t>mock: perfect</a:t>
-                      </a:r>
-                    </a:p>
-                  </a:txBody>
-                  <a:tcPr marL="73152" marR="73152" marT="18288" marB="18288" anchor="ctr">
-                    <a:solidFill>
-                      <a:srgbClr val="FFFFFF"/>
-                    </a:solidFill>
-                  </a:tcPr>
-                </a:tc>
-                <a:tc>
-                  <a:txBody>
-                    <a:bodyPr/>
-                    <a:lstStyle/>
-                    <a:p>
-                      <a:pPr algn="ctr">
-                        <a:lnSpc>
-                          <a:spcPct val="112000"/>
-                        </a:lnSpc>
-                        <a:spcAft>
-                          <a:spcPts val="100"/>
-                        </a:spcAft>
-                      </a:pPr>
-                      <a:r>
-                        <a:rPr sz="1150" b="0">
-                          <a:solidFill>
-                            <a:srgbClr val="2F2E2B"/>
-                          </a:solidFill>
-                          <a:latin typeface="Helvetica Neue"/>
-                        </a:rPr>
-                        <a:t>1.000</a:t>
-                      </a:r>
-                    </a:p>
-                  </a:txBody>
-                  <a:tcPr marL="73152" marR="73152" marT="18288" marB="18288" anchor="ctr">
-                    <a:solidFill>
-                      <a:srgbClr val="FFFFFF"/>
-                    </a:solidFill>
-                  </a:tcPr>
-                </a:tc>
-                <a:tc>
-                  <a:txBody>
-                    <a:bodyPr/>
-                    <a:lstStyle/>
-                    <a:p>
-                      <a:pPr algn="ctr">
-                        <a:lnSpc>
-                          <a:spcPct val="112000"/>
-                        </a:lnSpc>
-                        <a:spcAft>
-                          <a:spcPts val="100"/>
-                        </a:spcAft>
-                      </a:pPr>
-                      <a:r>
-                        <a:rPr sz="1150" b="0">
-                          <a:solidFill>
-                            <a:srgbClr val="2F2E2B"/>
-                          </a:solidFill>
-                          <a:latin typeface="Helvetica Neue"/>
-                        </a:rPr>
-                        <a:t>1.000</a:t>
-                      </a:r>
-                    </a:p>
-                  </a:txBody>
-                  <a:tcPr marL="73152" marR="73152" marT="18288" marB="18288" anchor="ctr">
-                    <a:solidFill>
-                      <a:srgbClr val="FFFFFF"/>
-                    </a:solidFill>
-                  </a:tcPr>
-                </a:tc>
-                <a:tc>
-                  <a:txBody>
-                    <a:bodyPr/>
-                    <a:lstStyle/>
-                    <a:p>
-                      <a:pPr algn="ctr">
-                        <a:lnSpc>
-                          <a:spcPct val="112000"/>
-                        </a:lnSpc>
-                        <a:spcAft>
-                          <a:spcPts val="100"/>
-                        </a:spcAft>
-                      </a:pPr>
-                      <a:r>
-                        <a:rPr sz="1150" b="0">
-                          <a:solidFill>
-                            <a:srgbClr val="2F2E2B"/>
-                          </a:solidFill>
-                          <a:latin typeface="Helvetica Neue"/>
-                        </a:rPr>
-                        <a:t>1.000</a:t>
-                      </a:r>
-                    </a:p>
-                  </a:txBody>
-                  <a:tcPr marL="73152" marR="73152" marT="18288" marB="18288" anchor="ctr">
-                    <a:solidFill>
-                      <a:srgbClr val="FFFFFF"/>
-                    </a:solidFill>
-                  </a:tcPr>
-                </a:tc>
-                <a:tc>
-                  <a:txBody>
-                    <a:bodyPr/>
-                    <a:lstStyle/>
-                    <a:p>
-                      <a:pPr algn="ctr">
-                        <a:lnSpc>
-                          <a:spcPct val="112000"/>
-                        </a:lnSpc>
-                        <a:spcAft>
-                          <a:spcPts val="100"/>
-                        </a:spcAft>
-                      </a:pPr>
-                      <a:r>
-                        <a:rPr sz="1150" b="0">
-                          <a:solidFill>
-                            <a:srgbClr val="2F2E2B"/>
-                          </a:solidFill>
-                          <a:latin typeface="Helvetica Neue"/>
-                        </a:rPr>
-                        <a:t>1.000</a:t>
-                      </a:r>
-                    </a:p>
-                  </a:txBody>
-                  <a:tcPr marL="73152" marR="73152" marT="18288" marB="18288" anchor="ctr">
-                    <a:solidFill>
-                      <a:srgbClr val="FFFFFF"/>
-                    </a:solidFill>
-                  </a:tcPr>
-                </a:tc>
-                <a:tc>
-                  <a:txBody>
-                    <a:bodyPr/>
-                    <a:lstStyle/>
-                    <a:p>
-                      <a:pPr algn="ctr">
-                        <a:lnSpc>
-                          <a:spcPct val="112000"/>
-                        </a:lnSpc>
-                        <a:spcAft>
-                          <a:spcPts val="100"/>
-                        </a:spcAft>
-                      </a:pPr>
-                      <a:r>
-                        <a:rPr sz="1150" b="0">
-                          <a:solidFill>
-                            <a:srgbClr val="2F2E2B"/>
-                          </a:solidFill>
-                          <a:latin typeface="Helvetica Neue"/>
-                        </a:rPr>
-                        <a:t>1.000</a:t>
-                      </a:r>
-                    </a:p>
-                  </a:txBody>
-                  <a:tcPr marL="73152" marR="73152" marT="18288" marB="18288" anchor="ctr">
-                    <a:solidFill>
-                      <a:srgbClr val="FFFFFF"/>
-                    </a:solidFill>
-                  </a:tcPr>
-                </a:tc>
-                <a:tc>
-                  <a:txBody>
-                    <a:bodyPr/>
-                    <a:lstStyle/>
-                    <a:p>
-                      <a:pPr algn="ctr">
-                        <a:lnSpc>
-                          <a:spcPct val="112000"/>
-                        </a:lnSpc>
-                        <a:spcAft>
-                          <a:spcPts val="100"/>
-                        </a:spcAft>
-                      </a:pPr>
-                      <a:r>
-                        <a:rPr sz="1150" b="0">
-                          <a:solidFill>
-                            <a:srgbClr val="2F2E2B"/>
-                          </a:solidFill>
-                          <a:latin typeface="Helvetica Neue"/>
-                        </a:rPr>
-                        <a:t>1.000</a:t>
-                      </a:r>
-                    </a:p>
-                  </a:txBody>
-                  <a:tcPr marL="73152" marR="73152" marT="18288" marB="18288" anchor="ctr">
-                    <a:solidFill>
-                      <a:srgbClr val="FFFFFF"/>
-                    </a:solidFill>
-                  </a:tcPr>
-                </a:tc>
-                <a:tc>
-                  <a:txBody>
-                    <a:bodyPr/>
-                    <a:lstStyle/>
-                    <a:p>
-                      <a:pPr algn="ctr">
-                        <a:lnSpc>
-                          <a:spcPct val="112000"/>
-                        </a:lnSpc>
-                        <a:spcAft>
-                          <a:spcPts val="100"/>
-                        </a:spcAft>
-                      </a:pPr>
-                      <a:r>
-                        <a:rPr sz="1150" b="0">
-                          <a:solidFill>
-                            <a:srgbClr val="2F2E2B"/>
-                          </a:solidFill>
-                          <a:latin typeface="Helvetica Neue"/>
-                        </a:rPr>
-                        <a:t>1.000</a:t>
-                      </a:r>
-                    </a:p>
-                  </a:txBody>
-                  <a:tcPr marL="73152" marR="73152" marT="18288" marB="18288" anchor="ctr">
-                    <a:solidFill>
-                      <a:srgbClr val="FFFFFF"/>
-                    </a:solidFill>
-                  </a:tcPr>
-                </a:tc>
-                <a:tc>
-                  <a:txBody>
-                    <a:bodyPr/>
-                    <a:lstStyle/>
-                    <a:p>
-                      <a:pPr algn="ctr">
-                        <a:lnSpc>
-                          <a:spcPct val="112000"/>
-                        </a:lnSpc>
-                        <a:spcAft>
-                          <a:spcPts val="100"/>
-                        </a:spcAft>
-                      </a:pPr>
-                      <a:r>
-                        <a:rPr sz="1150" b="0">
-                          <a:solidFill>
-                            <a:srgbClr val="2F2E2B"/>
-                          </a:solidFill>
-                          <a:latin typeface="Helvetica Neue"/>
-                        </a:rPr>
-                        <a:t>1.000</a:t>
-                      </a:r>
-                    </a:p>
-                  </a:txBody>
-                  <a:tcPr marL="73152" marR="73152" marT="18288" marB="18288" anchor="ctr">
-                    <a:solidFill>
-                      <a:srgbClr val="FFFFFF"/>
-                    </a:solidFill>
-                  </a:tcPr>
-                </a:tc>
-              </a:tr>
-              <a:tr h="384048">
-                <a:tc>
-                  <a:txBody>
-                    <a:bodyPr/>
-                    <a:lstStyle/>
-                    <a:p>
-                      <a:pPr algn="l">
-                        <a:lnSpc>
-                          <a:spcPct val="112000"/>
-                        </a:lnSpc>
-                        <a:spcAft>
-                          <a:spcPts val="100"/>
-                        </a:spcAft>
-                      </a:pPr>
-                      <a:r>
-                        <a:rPr sz="1150" b="0">
-                          <a:solidFill>
-                            <a:srgbClr val="2F2E2B"/>
-                          </a:solidFill>
-                          <a:latin typeface="Helvetica Neue"/>
-                        </a:rPr>
-                        <a:t>mock: ignore condition</a:t>
-                      </a:r>
-                    </a:p>
-                  </a:txBody>
-                  <a:tcPr marL="73152" marR="73152" marT="18288" marB="18288" anchor="ctr">
-                    <a:solidFill>
-                      <a:srgbClr val="FFFFFF"/>
-                    </a:solidFill>
-                  </a:tcPr>
-                </a:tc>
-                <a:tc>
-                  <a:txBody>
-                    <a:bodyPr/>
-                    <a:lstStyle/>
-                    <a:p>
-                      <a:pPr algn="ctr">
-                        <a:lnSpc>
-                          <a:spcPct val="112000"/>
-                        </a:lnSpc>
-                        <a:spcAft>
-                          <a:spcPts val="100"/>
-                        </a:spcAft>
-                      </a:pPr>
-                      <a:r>
-                        <a:rPr sz="1150" b="0">
-                          <a:solidFill>
-                            <a:srgbClr val="2F2E2B"/>
-                          </a:solidFill>
-                          <a:latin typeface="Helvetica Neue"/>
-                        </a:rPr>
-                        <a:t>1.000</a:t>
-                      </a:r>
-                    </a:p>
-                  </a:txBody>
-                  <a:tcPr marL="73152" marR="73152" marT="18288" marB="18288" anchor="ctr">
-                    <a:solidFill>
-                      <a:srgbClr val="FFFFFF"/>
-                    </a:solidFill>
-                  </a:tcPr>
-                </a:tc>
-                <a:tc>
-                  <a:txBody>
-                    <a:bodyPr/>
-                    <a:lstStyle/>
-                    <a:p>
-                      <a:pPr algn="ctr">
-                        <a:lnSpc>
-                          <a:spcPct val="112000"/>
-                        </a:lnSpc>
-                        <a:spcAft>
-                          <a:spcPts val="100"/>
-                        </a:spcAft>
-                      </a:pPr>
-                      <a:r>
-                        <a:rPr sz="1150" b="0">
-                          <a:solidFill>
-                            <a:srgbClr val="2F2E2B"/>
-                          </a:solidFill>
-                          <a:latin typeface="Helvetica Neue"/>
-                        </a:rPr>
-                        <a:t>0.497</a:t>
-                      </a:r>
-                    </a:p>
-                  </a:txBody>
-                  <a:tcPr marL="73152" marR="73152" marT="18288" marB="18288" anchor="ctr">
-                    <a:solidFill>
-                      <a:srgbClr val="FFFFFF"/>
-                    </a:solidFill>
-                  </a:tcPr>
-                </a:tc>
-                <a:tc>
-                  <a:txBody>
-                    <a:bodyPr/>
-                    <a:lstStyle/>
-                    <a:p>
-                      <a:pPr algn="ctr">
-                        <a:lnSpc>
-                          <a:spcPct val="112000"/>
-                        </a:lnSpc>
-                        <a:spcAft>
-                          <a:spcPts val="100"/>
-                        </a:spcAft>
-                      </a:pPr>
-                      <a:r>
-                        <a:rPr sz="1150" b="0">
-                          <a:solidFill>
-                            <a:srgbClr val="2F2E2B"/>
-                          </a:solidFill>
-                          <a:latin typeface="Helvetica Neue"/>
-                        </a:rPr>
-                        <a:t>0.789</a:t>
-                      </a:r>
-                    </a:p>
-                  </a:txBody>
-                  <a:tcPr marL="73152" marR="73152" marT="18288" marB="18288" anchor="ctr">
-                    <a:solidFill>
-                      <a:srgbClr val="FFFFFF"/>
-                    </a:solidFill>
-                  </a:tcPr>
-                </a:tc>
-                <a:tc>
-                  <a:txBody>
-                    <a:bodyPr/>
-                    <a:lstStyle/>
-                    <a:p>
-                      <a:pPr algn="ctr">
-                        <a:lnSpc>
-                          <a:spcPct val="112000"/>
-                        </a:lnSpc>
-                        <a:spcAft>
-                          <a:spcPts val="100"/>
-                        </a:spcAft>
-                      </a:pPr>
-                      <a:r>
-                        <a:rPr sz="1150" b="0">
-                          <a:solidFill>
-                            <a:srgbClr val="2F2E2B"/>
-                          </a:solidFill>
-                          <a:latin typeface="Helvetica Neue"/>
-                        </a:rPr>
-                        <a:t>0.722</a:t>
-                      </a:r>
-                    </a:p>
-                  </a:txBody>
-                  <a:tcPr marL="73152" marR="73152" marT="18288" marB="18288" anchor="ctr">
-                    <a:solidFill>
-                      <a:srgbClr val="FFFFFF"/>
-                    </a:solidFill>
-                  </a:tcPr>
-                </a:tc>
-                <a:tc>
-                  <a:txBody>
-                    <a:bodyPr/>
-                    <a:lstStyle/>
-                    <a:p>
-                      <a:pPr algn="ctr">
-                        <a:lnSpc>
-                          <a:spcPct val="112000"/>
-                        </a:lnSpc>
-                        <a:spcAft>
-                          <a:spcPts val="100"/>
-                        </a:spcAft>
-                      </a:pPr>
-                      <a:r>
-                        <a:rPr sz="1150" b="0">
-                          <a:solidFill>
-                            <a:srgbClr val="2F2E2B"/>
-                          </a:solidFill>
-                          <a:latin typeface="Helvetica Neue"/>
-                        </a:rPr>
-                        <a:t>0.590</a:t>
-                      </a:r>
-                    </a:p>
-                  </a:txBody>
-                  <a:tcPr marL="73152" marR="73152" marT="18288" marB="18288" anchor="ctr">
-                    <a:solidFill>
-                      <a:srgbClr val="FFFFFF"/>
-                    </a:solidFill>
-                  </a:tcPr>
-                </a:tc>
-                <a:tc>
-                  <a:txBody>
-                    <a:bodyPr/>
-                    <a:lstStyle/>
-                    <a:p>
-                      <a:pPr algn="ctr">
-                        <a:lnSpc>
-                          <a:spcPct val="112000"/>
-                        </a:lnSpc>
-                        <a:spcAft>
-                          <a:spcPts val="100"/>
-                        </a:spcAft>
-                      </a:pPr>
-                      <a:r>
-                        <a:rPr sz="1150" b="0">
-                          <a:solidFill>
-                            <a:srgbClr val="2F2E2B"/>
-                          </a:solidFill>
-                          <a:latin typeface="Helvetica Neue"/>
-                        </a:rPr>
-                        <a:t>0.749</a:t>
-                      </a:r>
-                    </a:p>
-                  </a:txBody>
-                  <a:tcPr marL="73152" marR="73152" marT="18288" marB="18288" anchor="ctr">
-                    <a:solidFill>
-                      <a:srgbClr val="FFFFFF"/>
-                    </a:solidFill>
-                  </a:tcPr>
-                </a:tc>
-                <a:tc>
-                  <a:txBody>
-                    <a:bodyPr/>
-                    <a:lstStyle/>
-                    <a:p>
-                      <a:pPr algn="ctr">
-                        <a:lnSpc>
-                          <a:spcPct val="112000"/>
-                        </a:lnSpc>
-                        <a:spcAft>
-                          <a:spcPts val="100"/>
-                        </a:spcAft>
-                      </a:pPr>
-                      <a:r>
-                        <a:rPr sz="1150" b="0">
-                          <a:solidFill>
-                            <a:srgbClr val="2F2E2B"/>
-                          </a:solidFill>
-                          <a:latin typeface="Helvetica Neue"/>
-                        </a:rPr>
-                        <a:t>0.910</a:t>
-                      </a:r>
-                    </a:p>
-                  </a:txBody>
-                  <a:tcPr marL="73152" marR="73152" marT="18288" marB="18288" anchor="ctr">
-                    <a:solidFill>
-                      <a:srgbClr val="FFFFFF"/>
-                    </a:solidFill>
-                  </a:tcPr>
-                </a:tc>
-                <a:tc>
-                  <a:txBody>
-                    <a:bodyPr/>
-                    <a:lstStyle/>
-                    <a:p>
-                      <a:pPr algn="ctr">
-                        <a:lnSpc>
-                          <a:spcPct val="112000"/>
-                        </a:lnSpc>
-                        <a:spcAft>
-                          <a:spcPts val="100"/>
-                        </a:spcAft>
-                      </a:pPr>
-                      <a:r>
-                        <a:rPr sz="1150" b="0">
-                          <a:solidFill>
-                            <a:srgbClr val="2F2E2B"/>
-                          </a:solidFill>
-                          <a:latin typeface="Helvetica Neue"/>
-                        </a:rPr>
-                        <a:t>0.764</a:t>
-                      </a:r>
-                    </a:p>
-                  </a:txBody>
-                  <a:tcPr marL="73152" marR="73152" marT="18288" marB="18288" anchor="ctr">
-                    <a:solidFill>
-                      <a:srgbClr val="FFFFFF"/>
-                    </a:solidFill>
-                  </a:tcPr>
-                </a:tc>
-              </a:tr>
-              <a:tr h="384048">
-                <a:tc>
-                  <a:txBody>
-                    <a:bodyPr/>
-                    <a:lstStyle/>
-                    <a:p>
-                      <a:pPr algn="l">
-                        <a:lnSpc>
-                          <a:spcPct val="112000"/>
-                        </a:lnSpc>
-                        <a:spcAft>
-                          <a:spcPts val="100"/>
-                        </a:spcAft>
-                      </a:pPr>
-                      <a:r>
-                        <a:rPr sz="1150" b="0">
-                          <a:solidFill>
-                            <a:srgbClr val="2F2E2B"/>
-                          </a:solidFill>
-                          <a:latin typeface="Helvetica Neue"/>
-                        </a:rPr>
-                        <a:t>mock: first match only</a:t>
-                      </a:r>
-                    </a:p>
-                  </a:txBody>
-                  <a:tcPr marL="73152" marR="73152" marT="18288" marB="18288" anchor="ctr">
-                    <a:solidFill>
-                      <a:srgbClr val="FFFFFF"/>
-                    </a:solidFill>
-                  </a:tcPr>
-                </a:tc>
-                <a:tc>
-                  <a:txBody>
-                    <a:bodyPr/>
-                    <a:lstStyle/>
-                    <a:p>
-                      <a:pPr algn="ctr">
-                        <a:lnSpc>
-                          <a:spcPct val="112000"/>
-                        </a:lnSpc>
-                        <a:spcAft>
-                          <a:spcPts val="100"/>
-                        </a:spcAft>
-                      </a:pPr>
-                      <a:r>
-                        <a:rPr sz="1150" b="0">
-                          <a:solidFill>
-                            <a:srgbClr val="2F2E2B"/>
-                          </a:solidFill>
-                          <a:latin typeface="Helvetica Neue"/>
-                        </a:rPr>
-                        <a:t>0.758</a:t>
-                      </a:r>
-                    </a:p>
-                  </a:txBody>
-                  <a:tcPr marL="73152" marR="73152" marT="18288" marB="18288" anchor="ctr">
-                    <a:solidFill>
-                      <a:srgbClr val="FFFFFF"/>
-                    </a:solidFill>
-                  </a:tcPr>
-                </a:tc>
-                <a:tc>
-                  <a:txBody>
-                    <a:bodyPr/>
-                    <a:lstStyle/>
-                    <a:p>
-                      <a:pPr algn="ctr">
-                        <a:lnSpc>
-                          <a:spcPct val="112000"/>
-                        </a:lnSpc>
-                        <a:spcAft>
-                          <a:spcPts val="100"/>
-                        </a:spcAft>
-                      </a:pPr>
-                      <a:r>
-                        <a:rPr sz="1150" b="0">
-                          <a:solidFill>
-                            <a:srgbClr val="2F2E2B"/>
-                          </a:solidFill>
-                          <a:latin typeface="Helvetica Neue"/>
-                        </a:rPr>
-                        <a:t>0.269</a:t>
-                      </a:r>
-                    </a:p>
-                  </a:txBody>
-                  <a:tcPr marL="73152" marR="73152" marT="18288" marB="18288" anchor="ctr">
-                    <a:solidFill>
-                      <a:srgbClr val="FFFFFF"/>
-                    </a:solidFill>
-                  </a:tcPr>
-                </a:tc>
-                <a:tc>
-                  <a:txBody>
-                    <a:bodyPr/>
-                    <a:lstStyle/>
-                    <a:p>
-                      <a:pPr algn="ctr">
-                        <a:lnSpc>
-                          <a:spcPct val="112000"/>
-                        </a:lnSpc>
-                        <a:spcAft>
-                          <a:spcPts val="100"/>
-                        </a:spcAft>
-                      </a:pPr>
-                      <a:r>
-                        <a:rPr sz="1150" b="0">
-                          <a:solidFill>
-                            <a:srgbClr val="2F2E2B"/>
-                          </a:solidFill>
-                          <a:latin typeface="Helvetica Neue"/>
-                        </a:rPr>
-                        <a:t>0.260</a:t>
-                      </a:r>
-                    </a:p>
-                  </a:txBody>
-                  <a:tcPr marL="73152" marR="73152" marT="18288" marB="18288" anchor="ctr">
-                    <a:solidFill>
-                      <a:srgbClr val="FFFFFF"/>
-                    </a:solidFill>
-                  </a:tcPr>
-                </a:tc>
-                <a:tc>
-                  <a:txBody>
-                    <a:bodyPr/>
-                    <a:lstStyle/>
-                    <a:p>
-                      <a:pPr algn="ctr">
-                        <a:lnSpc>
-                          <a:spcPct val="112000"/>
-                        </a:lnSpc>
-                        <a:spcAft>
-                          <a:spcPts val="100"/>
-                        </a:spcAft>
-                      </a:pPr>
-                      <a:r>
-                        <a:rPr sz="1150" b="0">
-                          <a:solidFill>
-                            <a:srgbClr val="2F2E2B"/>
-                          </a:solidFill>
-                          <a:latin typeface="Helvetica Neue"/>
-                        </a:rPr>
-                        <a:t>0.885</a:t>
-                      </a:r>
-                    </a:p>
-                  </a:txBody>
-                  <a:tcPr marL="73152" marR="73152" marT="18288" marB="18288" anchor="ctr">
-                    <a:solidFill>
-                      <a:srgbClr val="FFFFFF"/>
-                    </a:solidFill>
-                  </a:tcPr>
-                </a:tc>
-                <a:tc>
-                  <a:txBody>
-                    <a:bodyPr/>
-                    <a:lstStyle/>
-                    <a:p>
-                      <a:pPr algn="ctr">
-                        <a:lnSpc>
-                          <a:spcPct val="112000"/>
-                        </a:lnSpc>
-                        <a:spcAft>
-                          <a:spcPts val="100"/>
-                        </a:spcAft>
-                      </a:pPr>
-                      <a:r>
-                        <a:rPr sz="1150" b="0">
-                          <a:solidFill>
-                            <a:srgbClr val="2F2E2B"/>
-                          </a:solidFill>
-                          <a:latin typeface="Helvetica Neue"/>
-                        </a:rPr>
-                        <a:t>0.370</a:t>
-                      </a:r>
-                    </a:p>
-                  </a:txBody>
-                  <a:tcPr marL="73152" marR="73152" marT="18288" marB="18288" anchor="ctr">
-                    <a:solidFill>
-                      <a:srgbClr val="FFFFFF"/>
-                    </a:solidFill>
-                  </a:tcPr>
-                </a:tc>
-                <a:tc>
-                  <a:txBody>
-                    <a:bodyPr/>
-                    <a:lstStyle/>
-                    <a:p>
-                      <a:pPr algn="ctr">
-                        <a:lnSpc>
-                          <a:spcPct val="112000"/>
-                        </a:lnSpc>
-                        <a:spcAft>
-                          <a:spcPts val="100"/>
-                        </a:spcAft>
-                      </a:pPr>
-                      <a:r>
-                        <a:rPr sz="1150" b="0">
-                          <a:solidFill>
-                            <a:srgbClr val="2F2E2B"/>
-                          </a:solidFill>
-                          <a:latin typeface="Helvetica Neue"/>
-                        </a:rPr>
-                        <a:t>0.627</a:t>
-                      </a:r>
-                    </a:p>
-                  </a:txBody>
-                  <a:tcPr marL="73152" marR="73152" marT="18288" marB="18288" anchor="ctr">
-                    <a:solidFill>
-                      <a:srgbClr val="FFFFFF"/>
-                    </a:solidFill>
-                  </a:tcPr>
-                </a:tc>
-                <a:tc>
-                  <a:txBody>
-                    <a:bodyPr/>
-                    <a:lstStyle/>
-                    <a:p>
-                      <a:pPr algn="ctr">
-                        <a:lnSpc>
-                          <a:spcPct val="112000"/>
-                        </a:lnSpc>
-                        <a:spcAft>
-                          <a:spcPts val="100"/>
-                        </a:spcAft>
-                      </a:pPr>
-                      <a:r>
-                        <a:rPr sz="1150" b="0">
-                          <a:solidFill>
-                            <a:srgbClr val="2F2E2B"/>
-                          </a:solidFill>
-                          <a:latin typeface="Helvetica Neue"/>
-                        </a:rPr>
-                        <a:t>0.590</a:t>
-                      </a:r>
-                    </a:p>
-                  </a:txBody>
-                  <a:tcPr marL="73152" marR="73152" marT="18288" marB="18288" anchor="ctr">
-                    <a:solidFill>
-                      <a:srgbClr val="FFFFFF"/>
-                    </a:solidFill>
-                  </a:tcPr>
-                </a:tc>
-                <a:tc>
-                  <a:txBody>
-                    <a:bodyPr/>
-                    <a:lstStyle/>
-                    <a:p>
-                      <a:pPr algn="ctr">
-                        <a:lnSpc>
-                          <a:spcPct val="112000"/>
-                        </a:lnSpc>
-                        <a:spcAft>
-                          <a:spcPts val="100"/>
-                        </a:spcAft>
-                      </a:pPr>
-                      <a:r>
-                        <a:rPr sz="1150" b="0">
-                          <a:solidFill>
-                            <a:srgbClr val="2F2E2B"/>
-                          </a:solidFill>
-                          <a:latin typeface="Helvetica Neue"/>
-                        </a:rPr>
-                        <a:t>0.542</a:t>
-                      </a:r>
-                    </a:p>
-                  </a:txBody>
-                  <a:tcPr marL="73152" marR="73152" marT="18288" marB="18288" anchor="ctr">
-                    <a:solidFill>
-                      <a:srgbClr val="FFFFFF"/>
-                    </a:solidFill>
-                  </a:tcPr>
-                </a:tc>
-              </a:tr>
-            </a:tbl>
-          </a:graphicData>
-        </a:graphic>
-      </p:graphicFrame>
-      <p:sp>
-        <p:nvSpPr>
-          <p:cNvPr id="7" name="TextBox 6"/>
-          <p:cNvSpPr txBox="1"/>
-          <p:nvPr/>
-        </p:nvSpPr>
-        <p:spPr>
-          <a:xfrm>
-            <a:off x="713232" y="4892040"/>
-            <a:ext cx="10789920" cy="1097280"/>
-          </a:xfrm>
-          <a:prstGeom prst="rect">
-            <a:avLst/>
-          </a:prstGeom>
-          <a:noFill/>
-        </p:spPr>
-        <p:txBody>
-          <a:bodyPr wrap="square">
-            <a:spAutoFit/>
-          </a:bodyPr>
-          <a:lstStyle/>
-          <a:p>
-            <a:pPr>
-              <a:lnSpc>
-                <a:spcPct val="130000"/>
-              </a:lnSpc>
-              <a:spcAft>
-                <a:spcPts val="700"/>
-              </a:spcAft>
-            </a:pPr>
-            <a:r>
-              <a:rPr sz="1300" b="0">
-                <a:solidFill>
-                  <a:srgbClr val="52514E"/>
-                </a:solidFill>
-                <a:latin typeface="Helvetica Neue"/>
-              </a:rPr>
-              <a:t>Qwen2.5-Omni-7B, 4-bit, 699 held-out queries over composed ESC-50. Mock rows are scored on the full 4404-query benchmark and bound the achievable range: they are handed perfect grounding and have only their condition logic ablated.</a:t>
-            </a:r>
-          </a:p>
-          <a:p>
-            <a:pPr>
-              <a:lnSpc>
-                <a:spcPct val="130000"/>
-              </a:lnSpc>
-              <a:spcAft>
-                <a:spcPts val="700"/>
-              </a:spcAft>
-            </a:pPr>
-            <a:r>
-              <a:rPr sz="1300" b="0">
-                <a:solidFill>
-                  <a:srgbClr val="52514E"/>
-                </a:solidFill>
-                <a:latin typeface="Helvetica Neue"/>
-              </a:rPr>
-              <a:t>Code and documentation: </a:t>
-            </a:r>
-            <a:r>
-              <a:rPr sz="1300" b="1">
-                <a:solidFill>
-                  <a:srgbClr val="0B0B0B"/>
-                </a:solidFill>
-                <a:latin typeface="Helvetica Neue"/>
-              </a:rPr>
-              <a:t>github.com/Ani2512/mtech-project</a:t>
-            </a:r>
-            <a:r>
-              <a:rPr sz="1300" b="0">
-                <a:solidFill>
-                  <a:srgbClr val="52514E"/>
-                </a:solidFill>
-                <a:latin typeface="Helvetica Neue"/>
-              </a:rPr>
-              <a:t>, branch `compositional-temporal-grounding`.</a:t>
-            </a:r>
-          </a:p>
-        </p:txBody>
-      </p:sp>
     </p:spTree>
   </p:cSld>
   <p:clrMapOvr>

</xml_diff>

<commit_message>
Centre the title slide
Co-Authored-By: Claude Fable 5.1 <noreply@anthropic.com>
Claude-Session: https://claude.ai/code/session_01LW3CYoTQJimM7bQSY15feA
</commit_message>
<xml_diff>
--- a/research_project/presentation/Compositional_Temporal_Audio_Grounding_2026-09-12.pptx
+++ b/research_project/presentation/Compositional_Temporal_Audio_Grounding_2026-09-12.pptx
@@ -3157,8 +3157,8 @@
         </p:nvSpPr>
         <p:spPr>
           <a:xfrm>
-            <a:off x="1005840" y="2057400"/>
-            <a:ext cx="10058400" cy="1280160"/>
+            <a:off x="201168" y="2057400"/>
+            <a:ext cx="11990527" cy="1280160"/>
           </a:xfrm>
           <a:prstGeom prst="rect">
             <a:avLst/>
@@ -3171,7 +3171,7 @@
           </a:bodyPr>
           <a:lstStyle/>
           <a:p>
-            <a:pPr>
+            <a:pPr algn="ctr">
               <a:lnSpc>
                 <a:spcPct val="108000"/>
               </a:lnSpc>
@@ -3197,8 +3197,8 @@
         </p:nvSpPr>
         <p:spPr>
           <a:xfrm>
-            <a:off x="1005840" y="3611880"/>
-            <a:ext cx="10058400" cy="457200"/>
+            <a:off x="201168" y="3611880"/>
+            <a:ext cx="11990527" cy="457200"/>
           </a:xfrm>
           <a:prstGeom prst="rect">
             <a:avLst/>
@@ -3211,7 +3211,7 @@
           </a:bodyPr>
           <a:lstStyle/>
           <a:p>
-            <a:pPr>
+            <a:pPr algn="ctr">
               <a:lnSpc>
                 <a:spcPct val="130000"/>
               </a:lnSpc>
@@ -3257,8 +3257,8 @@
         </p:nvSpPr>
         <p:spPr>
           <a:xfrm>
-            <a:off x="1005840" y="4572000"/>
-            <a:ext cx="10058400" cy="1097280"/>
+            <a:off x="201168" y="4572000"/>
+            <a:ext cx="11990527" cy="1097280"/>
           </a:xfrm>
           <a:prstGeom prst="rect">
             <a:avLst/>
@@ -3271,7 +3271,7 @@
           </a:bodyPr>
           <a:lstStyle/>
           <a:p>
-            <a:pPr>
+            <a:pPr algn="ctr">
               <a:lnSpc>
                 <a:spcPct val="130000"/>
               </a:lnSpc>
@@ -3290,7 +3290,7 @@
             </a:r>
           </a:p>
           <a:p>
-            <a:pPr>
+            <a:pPr algn="ctr">
               <a:lnSpc>
                 <a:spcPct val="130000"/>
               </a:lnSpc>

</xml_diff>

<commit_message>
Add an architecture slide after 'What was built'
Build / Answer / Score in one diagram, with the CPU diagnostic shown feeding
arm B's composition. Speaker notes gain a section and later slides renumber.

Co-Authored-By: Claude Fable 5.1 <noreply@anthropic.com>
Claude-Session: https://claude.ai/code/session_01LW3CYoTQJimM7bQSY15feA
</commit_message>
<xml_diff>
--- a/research_project/presentation/Compositional_Temporal_Audio_Grounding_2026-09-12.pptx
+++ b/research_project/presentation/Compositional_Temporal_Audio_Grounding_2026-09-12.pptx
@@ -23,6 +23,7 @@
     <p:sldId id="271" r:id="rId22"/>
     <p:sldId id="272" r:id="rId23"/>
     <p:sldId id="273" r:id="rId24"/>
+    <p:sldId id="274" r:id="rId25"/>
   </p:sldIdLst>
   <p:sldSz cx="12191695" cy="6858000" type="screen4x3"/>
   <p:notesSz cx="6858000" cy="9144000"/>
@@ -3391,7 +3392,7 @@
                 </a:solidFill>
                 <a:latin typeface="Helvetica Neue"/>
               </a:rPr>
-              <a:t>Which produced a falsifiable prediction</a:t>
+              <a:t>Is the model bad at conditions, or bad at hearing?</a:t>
             </a:r>
           </a:p>
         </p:txBody>
@@ -3471,6 +3472,791 @@
                 <a:latin typeface="Helvetica Neue"/>
               </a:rPr>
               <a:t>10</a:t>
+            </a:r>
+          </a:p>
+        </p:txBody>
+      </p:sp>
+      <p:sp>
+        <p:nvSpPr>
+          <p:cNvPr id="6" name="TextBox 5"/>
+          <p:cNvSpPr txBox="1"/>
+          <p:nvPr/>
+        </p:nvSpPr>
+        <p:spPr>
+          <a:xfrm>
+            <a:off x="713232" y="1828800"/>
+            <a:ext cx="10789920" cy="548640"/>
+          </a:xfrm>
+          <a:prstGeom prst="rect">
+            <a:avLst/>
+          </a:prstGeom>
+          <a:noFill/>
+        </p:spPr>
+        <p:txBody>
+          <a:bodyPr wrap="square">
+            <a:spAutoFit/>
+          </a:bodyPr>
+          <a:lstStyle/>
+          <a:p>
+            <a:pPr>
+              <a:lnSpc>
+                <a:spcPct val="130000"/>
+              </a:lnSpc>
+              <a:spcAft>
+                <a:spcPts val="600"/>
+              </a:spcAft>
+            </a:pPr>
+            <a:r>
+              <a:rPr sz="1500" b="0">
+                <a:solidFill>
+                  <a:srgbClr val="52514E"/>
+                </a:solidFill>
+                <a:latin typeface="Helvetica Neue"/>
+              </a:rPr>
+              <a:t>Answer the condition </a:t>
+            </a:r>
+            <a:r>
+              <a:rPr sz="1500" b="1">
+                <a:solidFill>
+                  <a:srgbClr val="0B0B0B"/>
+                </a:solidFill>
+                <a:latin typeface="Helvetica Neue"/>
+              </a:rPr>
+              <a:t>for</a:t>
+            </a:r>
+            <a:r>
+              <a:rPr sz="1500" b="0">
+                <a:solidFill>
+                  <a:srgbClr val="52514E"/>
+                </a:solidFill>
+                <a:latin typeface="Helvetica Neue"/>
+              </a:rPr>
+              <a:t> the model: ground each sound separately, then apply the condition with the same predicates that define the ground truth. Then degrade the grounder on purpose.</a:t>
+            </a:r>
+          </a:p>
+        </p:txBody>
+      </p:sp>
+      <p:graphicFrame>
+        <p:nvGraphicFramePr>
+          <p:cNvPr id="7" name="Table 6"/>
+          <p:cNvGraphicFramePr>
+            <a:graphicFrameLocks noGrp="1"/>
+          </p:cNvGraphicFramePr>
+          <p:nvPr/>
+        </p:nvGraphicFramePr>
+        <p:xfrm>
+          <a:off x="713232" y="2651760"/>
+          <a:ext cx="7498078" cy="2651760"/>
+        </p:xfrm>
+        <a:graphic>
+          <a:graphicData uri="http://schemas.openxmlformats.org/drawingml/2006/table">
+            <a:tbl>
+              <a:tblPr firstRow="1">
+                <a:tableStyleId>{5C22544A-7EE6-4342-B048-85BDC9FD1C3A}</a:tableStyleId>
+              </a:tblPr>
+              <a:tblGrid>
+                <a:gridCol w="5120639"/>
+                <a:gridCol w="2377439"/>
+              </a:tblGrid>
+              <a:tr h="347472">
+                <a:tc>
+                  <a:txBody>
+                    <a:bodyPr/>
+                    <a:lstStyle/>
+                    <a:p>
+                      <a:pPr algn="l">
+                        <a:lnSpc>
+                          <a:spcPct val="112000"/>
+                        </a:lnSpc>
+                        <a:spcAft>
+                          <a:spcPts val="100"/>
+                        </a:spcAft>
+                      </a:pPr>
+                      <a:r>
+                        <a:rPr sz="1200" b="1">
+                          <a:solidFill>
+                            <a:srgbClr val="52514E"/>
+                          </a:solidFill>
+                          <a:latin typeface="Helvetica Neue"/>
+                        </a:rPr>
+                        <a:t>Grounding quality given to the composer</a:t>
+                      </a:r>
+                    </a:p>
+                  </a:txBody>
+                  <a:tcPr marL="73152" marR="73152" marT="18288" marB="18288" anchor="ctr">
+                    <a:solidFill>
+                      <a:srgbClr val="F4F7FC"/>
+                    </a:solidFill>
+                  </a:tcPr>
+                </a:tc>
+                <a:tc>
+                  <a:txBody>
+                    <a:bodyPr/>
+                    <a:lstStyle/>
+                    <a:p>
+                      <a:pPr algn="ctr">
+                        <a:lnSpc>
+                          <a:spcPct val="112000"/>
+                        </a:lnSpc>
+                        <a:spcAft>
+                          <a:spcPts val="100"/>
+                        </a:spcAft>
+                      </a:pPr>
+                      <a:r>
+                        <a:rPr sz="1200" b="1">
+                          <a:solidFill>
+                            <a:srgbClr val="52514E"/>
+                          </a:solidFill>
+                          <a:latin typeface="Helvetica Neue"/>
+                        </a:rPr>
+                        <a:t>f1@0.5, all 4404 queries</a:t>
+                      </a:r>
+                    </a:p>
+                  </a:txBody>
+                  <a:tcPr marL="73152" marR="73152" marT="18288" marB="18288" anchor="ctr">
+                    <a:solidFill>
+                      <a:srgbClr val="F4F7FC"/>
+                    </a:solidFill>
+                  </a:tcPr>
+                </a:tc>
+              </a:tr>
+              <a:tr h="384048">
+                <a:tc>
+                  <a:txBody>
+                    <a:bodyPr/>
+                    <a:lstStyle/>
+                    <a:p>
+                      <a:pPr algn="l">
+                        <a:lnSpc>
+                          <a:spcPct val="112000"/>
+                        </a:lnSpc>
+                        <a:spcAft>
+                          <a:spcPts val="100"/>
+                        </a:spcAft>
+                      </a:pPr>
+                      <a:r>
+                        <a:rPr sz="1350" b="0">
+                          <a:solidFill>
+                            <a:srgbClr val="2F2E2B"/>
+                          </a:solidFill>
+                          <a:latin typeface="Helvetica Neue"/>
+                        </a:rPr>
+                        <a:t>Perfect</a:t>
+                      </a:r>
+                    </a:p>
+                  </a:txBody>
+                  <a:tcPr marL="73152" marR="73152" marT="18288" marB="18288" anchor="ctr">
+                    <a:solidFill>
+                      <a:srgbClr val="FFFFFF"/>
+                    </a:solidFill>
+                  </a:tcPr>
+                </a:tc>
+                <a:tc>
+                  <a:txBody>
+                    <a:bodyPr/>
+                    <a:lstStyle/>
+                    <a:p>
+                      <a:pPr algn="ctr">
+                        <a:lnSpc>
+                          <a:spcPct val="112000"/>
+                        </a:lnSpc>
+                        <a:spcAft>
+                          <a:spcPts val="100"/>
+                        </a:spcAft>
+                      </a:pPr>
+                      <a:r>
+                        <a:rPr sz="1350" b="0">
+                          <a:solidFill>
+                            <a:srgbClr val="2F2E2B"/>
+                          </a:solidFill>
+                          <a:latin typeface="Helvetica Neue"/>
+                        </a:rPr>
+                        <a:t>1.000</a:t>
+                      </a:r>
+                    </a:p>
+                  </a:txBody>
+                  <a:tcPr marL="73152" marR="73152" marT="18288" marB="18288" anchor="ctr">
+                    <a:solidFill>
+                      <a:srgbClr val="FFFFFF"/>
+                    </a:solidFill>
+                  </a:tcPr>
+                </a:tc>
+              </a:tr>
+              <a:tr h="384048">
+                <a:tc>
+                  <a:txBody>
+                    <a:bodyPr/>
+                    <a:lstStyle/>
+                    <a:p>
+                      <a:pPr algn="l">
+                        <a:lnSpc>
+                          <a:spcPct val="112000"/>
+                        </a:lnSpc>
+                        <a:spcAft>
+                          <a:spcPts val="100"/>
+                        </a:spcAft>
+                      </a:pPr>
+                      <a:r>
+                        <a:rPr sz="1350" b="0">
+                          <a:solidFill>
+                            <a:srgbClr val="2F2E2B"/>
+                          </a:solidFill>
+                          <a:latin typeface="Helvetica Neue"/>
+                        </a:rPr>
+                        <a:t>Boundaries jittered ±0.5 s</a:t>
+                      </a:r>
+                    </a:p>
+                  </a:txBody>
+                  <a:tcPr marL="73152" marR="73152" marT="18288" marB="18288" anchor="ctr">
+                    <a:solidFill>
+                      <a:srgbClr val="FFFFFF"/>
+                    </a:solidFill>
+                  </a:tcPr>
+                </a:tc>
+                <a:tc>
+                  <a:txBody>
+                    <a:bodyPr/>
+                    <a:lstStyle/>
+                    <a:p>
+                      <a:pPr algn="ctr">
+                        <a:lnSpc>
+                          <a:spcPct val="112000"/>
+                        </a:lnSpc>
+                        <a:spcAft>
+                          <a:spcPts val="100"/>
+                        </a:spcAft>
+                      </a:pPr>
+                      <a:r>
+                        <a:rPr sz="1350" b="0">
+                          <a:solidFill>
+                            <a:srgbClr val="2F2E2B"/>
+                          </a:solidFill>
+                          <a:latin typeface="Helvetica Neue"/>
+                        </a:rPr>
+                        <a:t>0.925</a:t>
+                      </a:r>
+                    </a:p>
+                  </a:txBody>
+                  <a:tcPr marL="73152" marR="73152" marT="18288" marB="18288" anchor="ctr">
+                    <a:solidFill>
+                      <a:srgbClr val="FFFFFF"/>
+                    </a:solidFill>
+                  </a:tcPr>
+                </a:tc>
+              </a:tr>
+              <a:tr h="384048">
+                <a:tc>
+                  <a:txBody>
+                    <a:bodyPr/>
+                    <a:lstStyle/>
+                    <a:p>
+                      <a:pPr algn="l">
+                        <a:lnSpc>
+                          <a:spcPct val="112000"/>
+                        </a:lnSpc>
+                        <a:spcAft>
+                          <a:spcPts val="100"/>
+                        </a:spcAft>
+                      </a:pPr>
+                      <a:r>
+                        <a:rPr sz="1350" b="0">
+                          <a:solidFill>
+                            <a:srgbClr val="2F2E2B"/>
+                          </a:solidFill>
+                          <a:latin typeface="Helvetica Neue"/>
+                        </a:rPr>
+                        <a:t>25% of events missed</a:t>
+                      </a:r>
+                    </a:p>
+                  </a:txBody>
+                  <a:tcPr marL="73152" marR="73152" marT="18288" marB="18288" anchor="ctr">
+                    <a:solidFill>
+                      <a:srgbClr val="FFFFFF"/>
+                    </a:solidFill>
+                  </a:tcPr>
+                </a:tc>
+                <a:tc>
+                  <a:txBody>
+                    <a:bodyPr/>
+                    <a:lstStyle/>
+                    <a:p>
+                      <a:pPr algn="ctr">
+                        <a:lnSpc>
+                          <a:spcPct val="112000"/>
+                        </a:lnSpc>
+                        <a:spcAft>
+                          <a:spcPts val="100"/>
+                        </a:spcAft>
+                      </a:pPr>
+                      <a:r>
+                        <a:rPr sz="1350" b="0">
+                          <a:solidFill>
+                            <a:srgbClr val="2F2E2B"/>
+                          </a:solidFill>
+                          <a:latin typeface="Helvetica Neue"/>
+                        </a:rPr>
+                        <a:t>0.650</a:t>
+                      </a:r>
+                    </a:p>
+                  </a:txBody>
+                  <a:tcPr marL="73152" marR="73152" marT="18288" marB="18288" anchor="ctr">
+                    <a:solidFill>
+                      <a:srgbClr val="FFFFFF"/>
+                    </a:solidFill>
+                  </a:tcPr>
+                </a:tc>
+              </a:tr>
+              <a:tr h="384048">
+                <a:tc>
+                  <a:txBody>
+                    <a:bodyPr/>
+                    <a:lstStyle/>
+                    <a:p>
+                      <a:pPr algn="l">
+                        <a:lnSpc>
+                          <a:spcPct val="112000"/>
+                        </a:lnSpc>
+                        <a:spcAft>
+                          <a:spcPts val="100"/>
+                        </a:spcAft>
+                      </a:pPr>
+                      <a:r>
+                        <a:rPr sz="1350" b="0">
+                          <a:solidFill>
+                            <a:srgbClr val="2F2E2B"/>
+                          </a:solidFill>
+                          <a:latin typeface="Helvetica Neue"/>
+                        </a:rPr>
+                        <a:t>25% spurious detections</a:t>
+                      </a:r>
+                    </a:p>
+                  </a:txBody>
+                  <a:tcPr marL="73152" marR="73152" marT="18288" marB="18288" anchor="ctr">
+                    <a:solidFill>
+                      <a:srgbClr val="FFFFFF"/>
+                    </a:solidFill>
+                  </a:tcPr>
+                </a:tc>
+                <a:tc>
+                  <a:txBody>
+                    <a:bodyPr/>
+                    <a:lstStyle/>
+                    <a:p>
+                      <a:pPr algn="ctr">
+                        <a:lnSpc>
+                          <a:spcPct val="112000"/>
+                        </a:lnSpc>
+                        <a:spcAft>
+                          <a:spcPts val="100"/>
+                        </a:spcAft>
+                      </a:pPr>
+                      <a:r>
+                        <a:rPr sz="1350" b="0">
+                          <a:solidFill>
+                            <a:srgbClr val="2F2E2B"/>
+                          </a:solidFill>
+                          <a:latin typeface="Helvetica Neue"/>
+                        </a:rPr>
+                        <a:t>0.937</a:t>
+                      </a:r>
+                    </a:p>
+                  </a:txBody>
+                  <a:tcPr marL="73152" marR="73152" marT="18288" marB="18288" anchor="ctr">
+                    <a:solidFill>
+                      <a:srgbClr val="FFFFFF"/>
+                    </a:solidFill>
+                  </a:tcPr>
+                </a:tc>
+              </a:tr>
+              <a:tr h="384048">
+                <a:tc>
+                  <a:txBody>
+                    <a:bodyPr/>
+                    <a:lstStyle/>
+                    <a:p>
+                      <a:pPr algn="l">
+                        <a:lnSpc>
+                          <a:spcPct val="112000"/>
+                        </a:lnSpc>
+                        <a:spcAft>
+                          <a:spcPts val="100"/>
+                        </a:spcAft>
+                      </a:pPr>
+                      <a:r>
+                        <a:rPr sz="1350" b="0">
+                          <a:solidFill>
+                            <a:srgbClr val="2F2E2B"/>
+                          </a:solidFill>
+                          <a:latin typeface="Helvetica Neue"/>
+                        </a:rPr>
+                        <a:t>Degraded until PLAIN matches Qwen2.5-Omni</a:t>
+                      </a:r>
+                    </a:p>
+                  </a:txBody>
+                  <a:tcPr marL="73152" marR="73152" marT="18288" marB="18288" anchor="ctr">
+                    <a:solidFill>
+                      <a:srgbClr val="FFFFFF"/>
+                    </a:solidFill>
+                  </a:tcPr>
+                </a:tc>
+                <a:tc>
+                  <a:txBody>
+                    <a:bodyPr/>
+                    <a:lstStyle/>
+                    <a:p>
+                      <a:pPr algn="ctr">
+                        <a:lnSpc>
+                          <a:spcPct val="112000"/>
+                        </a:lnSpc>
+                        <a:spcAft>
+                          <a:spcPts val="100"/>
+                        </a:spcAft>
+                      </a:pPr>
+                      <a:r>
+                        <a:rPr sz="1350" b="1">
+                          <a:solidFill>
+                            <a:srgbClr val="2A78D6"/>
+                          </a:solidFill>
+                          <a:latin typeface="Helvetica Neue"/>
+                        </a:rPr>
+                        <a:t>0.263</a:t>
+                      </a:r>
+                    </a:p>
+                  </a:txBody>
+                  <a:tcPr marL="73152" marR="73152" marT="18288" marB="18288" anchor="ctr">
+                    <a:solidFill>
+                      <a:srgbClr val="FFFFFF"/>
+                    </a:solidFill>
+                  </a:tcPr>
+                </a:tc>
+              </a:tr>
+              <a:tr h="384048">
+                <a:tc>
+                  <a:txBody>
+                    <a:bodyPr/>
+                    <a:lstStyle/>
+                    <a:p>
+                      <a:pPr algn="l">
+                        <a:lnSpc>
+                          <a:spcPct val="112000"/>
+                        </a:lnSpc>
+                        <a:spcAft>
+                          <a:spcPts val="100"/>
+                        </a:spcAft>
+                      </a:pPr>
+                      <a:r>
+                        <a:rPr sz="1350" b="0">
+                          <a:solidFill>
+                            <a:srgbClr val="2F2E2B"/>
+                          </a:solidFill>
+                          <a:latin typeface="Helvetica Neue"/>
+                        </a:rPr>
+                        <a:t>Qwen2.5-Omni answering directly</a:t>
+                      </a:r>
+                    </a:p>
+                  </a:txBody>
+                  <a:tcPr marL="73152" marR="73152" marT="18288" marB="18288" anchor="ctr">
+                    <a:solidFill>
+                      <a:srgbClr val="FFFFFF"/>
+                    </a:solidFill>
+                  </a:tcPr>
+                </a:tc>
+                <a:tc>
+                  <a:txBody>
+                    <a:bodyPr/>
+                    <a:lstStyle/>
+                    <a:p>
+                      <a:pPr algn="ctr">
+                        <a:lnSpc>
+                          <a:spcPct val="112000"/>
+                        </a:lnSpc>
+                        <a:spcAft>
+                          <a:spcPts val="100"/>
+                        </a:spcAft>
+                      </a:pPr>
+                      <a:r>
+                        <a:rPr sz="1350" b="1">
+                          <a:solidFill>
+                            <a:srgbClr val="2A78D6"/>
+                          </a:solidFill>
+                          <a:latin typeface="Helvetica Neue"/>
+                        </a:rPr>
+                        <a:t>0.243</a:t>
+                      </a:r>
+                    </a:p>
+                  </a:txBody>
+                  <a:tcPr marL="73152" marR="73152" marT="18288" marB="18288" anchor="ctr">
+                    <a:solidFill>
+                      <a:srgbClr val="FFFFFF"/>
+                    </a:solidFill>
+                  </a:tcPr>
+                </a:tc>
+              </a:tr>
+            </a:tbl>
+          </a:graphicData>
+        </a:graphic>
+      </p:graphicFrame>
+      <p:sp>
+        <p:nvSpPr>
+          <p:cNvPr id="8" name="Rectangle 7"/>
+          <p:cNvSpPr/>
+          <p:nvPr/>
+        </p:nvSpPr>
+        <p:spPr>
+          <a:xfrm>
+            <a:off x="8595360" y="2651760"/>
+            <a:ext cx="2880360" cy="2688336"/>
+          </a:xfrm>
+          <a:prstGeom prst="rect">
+            <a:avLst/>
+          </a:prstGeom>
+          <a:solidFill>
+            <a:srgbClr val="F4F7FC"/>
+          </a:solidFill>
+          <a:ln w="9525">
+            <a:solidFill>
+              <a:srgbClr val="2A78D6"/>
+            </a:solidFill>
+          </a:ln>
+          <a:effectLst/>
+        </p:spPr>
+        <p:style>
+          <a:lnRef idx="1">
+            <a:schemeClr val="accent1"/>
+          </a:lnRef>
+          <a:fillRef idx="3">
+            <a:schemeClr val="accent1"/>
+          </a:fillRef>
+          <a:effectRef idx="2">
+            <a:schemeClr val="accent1"/>
+          </a:effectRef>
+          <a:fontRef idx="minor">
+            <a:schemeClr val="lt1"/>
+          </a:fontRef>
+        </p:style>
+        <p:txBody>
+          <a:bodyPr rtlCol="0" anchor="ctr" wrap="square" lIns="201168" rIns="201168" tIns="128016" bIns="128016"/>
+          <a:lstStyle/>
+          <a:p>
+            <a:pPr algn="ctr">
+              <a:lnSpc>
+                <a:spcPct val="130000"/>
+              </a:lnSpc>
+              <a:spcAft>
+                <a:spcPts val="200"/>
+              </a:spcAft>
+            </a:pPr>
+            <a:r>
+              <a:rPr sz="1400" b="0">
+                <a:solidFill>
+                  <a:srgbClr val="52514E"/>
+                </a:solidFill>
+                <a:latin typeface="Helvetica Neue"/>
+              </a:rPr>
+              <a:t>Perfect events give </a:t>
+            </a:r>
+            <a:r>
+              <a:rPr sz="1400" b="1">
+                <a:solidFill>
+                  <a:srgbClr val="0B0B0B"/>
+                </a:solidFill>
+                <a:latin typeface="Helvetica Neue"/>
+              </a:rPr>
+              <a:t>1.000</a:t>
+            </a:r>
+            <a:r>
+              <a:rPr sz="1400" b="0">
+                <a:solidFill>
+                  <a:srgbClr val="52514E"/>
+                </a:solidFill>
+                <a:latin typeface="Helvetica Neue"/>
+              </a:rPr>
+              <a:t> on every condition type.
+So the conditions are trivial.
+</a:t>
+            </a:r>
+            <a:r>
+              <a:rPr sz="1400" b="1">
+                <a:solidFill>
+                  <a:srgbClr val="0B0B0B"/>
+                </a:solidFill>
+                <a:latin typeface="Helvetica Neue"/>
+              </a:rPr>
+              <a:t>Grounding quality is the binding constraint</a:t>
+            </a:r>
+            <a:r>
+              <a:rPr sz="1400" b="0">
+                <a:solidFill>
+                  <a:srgbClr val="52514E"/>
+                </a:solidFill>
+                <a:latin typeface="Helvetica Neue"/>
+              </a:rPr>
+              <a:t> — essentially the whole gap from 1.000 to 0.26.</a:t>
+            </a:r>
+          </a:p>
+        </p:txBody>
+      </p:sp>
+    </p:spTree>
+  </p:cSld>
+  <p:clrMapOvr>
+    <a:masterClrMapping/>
+  </p:clrMapOvr>
+</p:sld>
+</file>
+
+<file path=ppt/slides/slide11.xml><?xml version="1.0" encoding="utf-8"?>
+<p:sld xmlns:a="http://schemas.openxmlformats.org/drawingml/2006/main" xmlns:p="http://schemas.openxmlformats.org/presentationml/2006/main" xmlns:r="http://schemas.openxmlformats.org/officeDocument/2006/relationships">
+  <p:cSld>
+    <p:spTree>
+      <p:nvGrpSpPr>
+        <p:cNvPr id="1" name=""/>
+        <p:cNvGrpSpPr/>
+        <p:nvPr/>
+      </p:nvGrpSpPr>
+      <p:grpSpPr/>
+      <p:sp>
+        <p:nvSpPr>
+          <p:cNvPr id="2" name="TextBox 1"/>
+          <p:cNvSpPr txBox="1"/>
+          <p:nvPr/>
+        </p:nvSpPr>
+        <p:spPr>
+          <a:xfrm>
+            <a:off x="713232" y="475488"/>
+            <a:ext cx="10765231" cy="274320"/>
+          </a:xfrm>
+          <a:prstGeom prst="rect">
+            <a:avLst/>
+          </a:prstGeom>
+          <a:noFill/>
+        </p:spPr>
+        <p:txBody>
+          <a:bodyPr wrap="none">
+            <a:spAutoFit/>
+          </a:bodyPr>
+          <a:lstStyle/>
+          <a:p>
+            <a:r>
+              <a:rPr sz="1150" b="1">
+                <a:solidFill>
+                  <a:srgbClr val="8A8880"/>
+                </a:solidFill>
+                <a:latin typeface="Helvetica Neue"/>
+              </a:rPr>
+              <a:t>THE DIAGNOSTIC</a:t>
+            </a:r>
+          </a:p>
+        </p:txBody>
+      </p:sp>
+      <p:sp>
+        <p:nvSpPr>
+          <p:cNvPr id="3" name="TextBox 2"/>
+          <p:cNvSpPr txBox="1"/>
+          <p:nvPr/>
+        </p:nvSpPr>
+        <p:spPr>
+          <a:xfrm>
+            <a:off x="713232" y="786384"/>
+            <a:ext cx="10765231" cy="566928"/>
+          </a:xfrm>
+          <a:prstGeom prst="rect">
+            <a:avLst/>
+          </a:prstGeom>
+          <a:noFill/>
+        </p:spPr>
+        <p:txBody>
+          <a:bodyPr wrap="none">
+            <a:spAutoFit/>
+          </a:bodyPr>
+          <a:lstStyle/>
+          <a:p>
+            <a:r>
+              <a:rPr sz="2900" b="1">
+                <a:solidFill>
+                  <a:srgbClr val="0B0B0B"/>
+                </a:solidFill>
+                <a:latin typeface="Helvetica Neue"/>
+              </a:rPr>
+              <a:t>Which produced a falsifiable prediction</a:t>
+            </a:r>
+          </a:p>
+        </p:txBody>
+      </p:sp>
+      <p:sp>
+        <p:nvSpPr>
+          <p:cNvPr id="4" name="Rectangle 3"/>
+          <p:cNvSpPr/>
+          <p:nvPr/>
+        </p:nvSpPr>
+        <p:spPr>
+          <a:xfrm>
+            <a:off x="713232" y="1408176"/>
+            <a:ext cx="960120" cy="38100"/>
+          </a:xfrm>
+          <a:prstGeom prst="rect">
+            <a:avLst/>
+          </a:prstGeom>
+          <a:solidFill>
+            <a:srgbClr val="2A78D6"/>
+          </a:solidFill>
+          <a:ln>
+            <a:noFill/>
+          </a:ln>
+          <a:effectLst/>
+        </p:spPr>
+        <p:style>
+          <a:lnRef idx="1">
+            <a:schemeClr val="accent1"/>
+          </a:lnRef>
+          <a:fillRef idx="3">
+            <a:schemeClr val="accent1"/>
+          </a:fillRef>
+          <a:effectRef idx="2">
+            <a:schemeClr val="accent1"/>
+          </a:effectRef>
+          <a:fontRef idx="minor">
+            <a:schemeClr val="lt1"/>
+          </a:fontRef>
+        </p:style>
+        <p:txBody>
+          <a:bodyPr rtlCol="0" anchor="ctr"/>
+          <a:lstStyle/>
+          <a:p>
+            <a:pPr algn="ctr"/>
+          </a:p>
+        </p:txBody>
+      </p:sp>
+      <p:sp>
+        <p:nvSpPr>
+          <p:cNvPr id="5" name="TextBox 4"/>
+          <p:cNvSpPr txBox="1"/>
+          <p:nvPr/>
+        </p:nvSpPr>
+        <p:spPr>
+          <a:xfrm>
+            <a:off x="10381183" y="6382512"/>
+            <a:ext cx="1097280" cy="274320"/>
+          </a:xfrm>
+          <a:prstGeom prst="rect">
+            <a:avLst/>
+          </a:prstGeom>
+          <a:noFill/>
+        </p:spPr>
+        <p:txBody>
+          <a:bodyPr wrap="none">
+            <a:spAutoFit/>
+          </a:bodyPr>
+          <a:lstStyle/>
+          <a:p>
+            <a:pPr algn="r"/>
+            <a:r>
+              <a:rPr sz="1000">
+                <a:solidFill>
+                  <a:srgbClr val="8A8880"/>
+                </a:solidFill>
+                <a:latin typeface="Helvetica Neue"/>
+              </a:rPr>
+              <a:t>11</a:t>
             </a:r>
           </a:p>
         </p:txBody>
@@ -3849,7 +4635,7 @@
 </p:sld>
 </file>
 
-<file path=ppt/slides/slide11.xml><?xml version="1.0" encoding="utf-8"?>
+<file path=ppt/slides/slide12.xml><?xml version="1.0" encoding="utf-8"?>
 <p:sld xmlns:a="http://schemas.openxmlformats.org/drawingml/2006/main" xmlns:p="http://schemas.openxmlformats.org/presentationml/2006/main" xmlns:r="http://schemas.openxmlformats.org/officeDocument/2006/relationships">
   <p:cSld>
     <p:spTree>
@@ -4001,7 +4787,7 @@
                 </a:solidFill>
                 <a:latin typeface="Helvetica Neue"/>
               </a:rPr>
-              <a:t>11</a:t>
+              <a:t>12</a:t>
             </a:r>
           </a:p>
         </p:txBody>
@@ -4117,7 +4903,7 @@
 </p:sld>
 </file>
 
-<file path=ppt/slides/slide12.xml><?xml version="1.0" encoding="utf-8"?>
+<file path=ppt/slides/slide13.xml><?xml version="1.0" encoding="utf-8"?>
 <p:sld xmlns:a="http://schemas.openxmlformats.org/drawingml/2006/main" xmlns:p="http://schemas.openxmlformats.org/presentationml/2006/main" xmlns:r="http://schemas.openxmlformats.org/officeDocument/2006/relationships">
   <p:cSld>
     <p:spTree>
@@ -4269,7 +5055,7 @@
                 </a:solidFill>
                 <a:latin typeface="Helvetica Neue"/>
               </a:rPr>
-              <a:t>12</a:t>
+              <a:t>13</a:t>
             </a:r>
           </a:p>
         </p:txBody>
@@ -4457,7 +5243,7 @@
 </p:sld>
 </file>
 
-<file path=ppt/slides/slide13.xml><?xml version="1.0" encoding="utf-8"?>
+<file path=ppt/slides/slide14.xml><?xml version="1.0" encoding="utf-8"?>
 <p:sld xmlns:a="http://schemas.openxmlformats.org/drawingml/2006/main" xmlns:p="http://schemas.openxmlformats.org/presentationml/2006/main" xmlns:r="http://schemas.openxmlformats.org/officeDocument/2006/relationships">
   <p:cSld>
     <p:spTree>
@@ -4609,7 +5395,7 @@
                 </a:solidFill>
                 <a:latin typeface="Helvetica Neue"/>
               </a:rPr>
-              <a:t>13</a:t>
+              <a:t>14</a:t>
             </a:r>
           </a:p>
         </p:txBody>
@@ -5236,7 +6022,7 @@
 </p:sld>
 </file>
 
-<file path=ppt/slides/slide14.xml><?xml version="1.0" encoding="utf-8"?>
+<file path=ppt/slides/slide15.xml><?xml version="1.0" encoding="utf-8"?>
 <p:sld xmlns:a="http://schemas.openxmlformats.org/drawingml/2006/main" xmlns:p="http://schemas.openxmlformats.org/presentationml/2006/main" xmlns:r="http://schemas.openxmlformats.org/officeDocument/2006/relationships">
   <p:cSld>
     <p:spTree>
@@ -5388,7 +6174,7 @@
                 </a:solidFill>
                 <a:latin typeface="Helvetica Neue"/>
               </a:rPr>
-              <a:t>14</a:t>
+              <a:t>15</a:t>
             </a:r>
           </a:p>
         </p:txBody>
@@ -5540,7 +6326,7 @@
 </p:sld>
 </file>
 
-<file path=ppt/slides/slide15.xml><?xml version="1.0" encoding="utf-8"?>
+<file path=ppt/slides/slide16.xml><?xml version="1.0" encoding="utf-8"?>
 <p:sld xmlns:a="http://schemas.openxmlformats.org/drawingml/2006/main" xmlns:p="http://schemas.openxmlformats.org/presentationml/2006/main" xmlns:r="http://schemas.openxmlformats.org/officeDocument/2006/relationships">
   <p:cSld>
     <p:spTree>
@@ -5692,7 +6478,7 @@
                 </a:solidFill>
                 <a:latin typeface="Helvetica Neue"/>
               </a:rPr>
-              <a:t>15</a:t>
+              <a:t>16</a:t>
             </a:r>
           </a:p>
         </p:txBody>
@@ -6363,7 +7149,7 @@
 </p:sld>
 </file>
 
-<file path=ppt/slides/slide16.xml><?xml version="1.0" encoding="utf-8"?>
+<file path=ppt/slides/slide17.xml><?xml version="1.0" encoding="utf-8"?>
 <p:sld xmlns:a="http://schemas.openxmlformats.org/drawingml/2006/main" xmlns:p="http://schemas.openxmlformats.org/presentationml/2006/main" xmlns:r="http://schemas.openxmlformats.org/officeDocument/2006/relationships">
   <p:cSld>
     <p:spTree>
@@ -6515,7 +7301,7 @@
                 </a:solidFill>
                 <a:latin typeface="Helvetica Neue"/>
               </a:rPr>
-              <a:t>16</a:t>
+              <a:t>17</a:t>
             </a:r>
           </a:p>
         </p:txBody>
@@ -6719,7 +7505,7 @@
 </p:sld>
 </file>
 
-<file path=ppt/slides/slide17.xml><?xml version="1.0" encoding="utf-8"?>
+<file path=ppt/slides/slide18.xml><?xml version="1.0" encoding="utf-8"?>
 <p:sld xmlns:a="http://schemas.openxmlformats.org/drawingml/2006/main" xmlns:p="http://schemas.openxmlformats.org/presentationml/2006/main" xmlns:r="http://schemas.openxmlformats.org/officeDocument/2006/relationships">
   <p:cSld>
     <p:spTree>
@@ -6871,7 +7657,7 @@
                 </a:solidFill>
                 <a:latin typeface="Helvetica Neue"/>
               </a:rPr>
-              <a:t>17</a:t>
+              <a:t>18</a:t>
             </a:r>
           </a:p>
         </p:txBody>
@@ -7508,7 +8294,7 @@
 </p:sld>
 </file>
 
-<file path=ppt/slides/slide18.xml><?xml version="1.0" encoding="utf-8"?>
+<file path=ppt/slides/slide19.xml><?xml version="1.0" encoding="utf-8"?>
 <p:sld xmlns:a="http://schemas.openxmlformats.org/drawingml/2006/main" xmlns:p="http://schemas.openxmlformats.org/presentationml/2006/main" xmlns:r="http://schemas.openxmlformats.org/officeDocument/2006/relationships">
   <p:cSld>
     <p:spTree>
@@ -7660,7 +8446,7 @@
                 </a:solidFill>
                 <a:latin typeface="Helvetica Neue"/>
               </a:rPr>
-              <a:t>18</a:t>
+              <a:t>19</a:t>
             </a:r>
           </a:p>
         </p:txBody>
@@ -13577,7 +14363,7 @@
                 </a:solidFill>
                 <a:latin typeface="Helvetica Neue"/>
               </a:rPr>
-              <a:t>PHASE 1</a:t>
+              <a:t>SYSTEM</a:t>
             </a:r>
           </a:p>
         </p:txBody>
@@ -13611,7 +14397,7 @@
                 </a:solidFill>
                 <a:latin typeface="Helvetica Neue"/>
               </a:rPr>
-              <a:t>Only one of the two candidate backbones can ground at all</a:t>
+              <a:t>Architecture, as it runs today</a:t>
             </a:r>
           </a:p>
         </p:txBody>
@@ -13697,7 +14483,7 @@
       </p:sp>
       <p:pic>
         <p:nvPicPr>
-          <p:cNvPr id="6" name="Picture 5" descr="fig1_backbone.png"/>
+          <p:cNvPr id="6" name="Picture 5" descr="fig5_architecture.png"/>
           <p:cNvPicPr>
             <a:picLocks noChangeAspect="1"/>
           </p:cNvPicPr>
@@ -13711,8 +14497,8 @@
         </p:blipFill>
         <p:spPr>
           <a:xfrm>
-            <a:off x="1766031" y="1828800"/>
-            <a:ext cx="8659632" cy="3383280"/>
+            <a:off x="1652162" y="1645920"/>
+            <a:ext cx="8887370" cy="4160520"/>
           </a:xfrm>
           <a:prstGeom prst="rect">
             <a:avLst/>
@@ -13721,106 +14507,116 @@
       </p:pic>
       <p:sp>
         <p:nvSpPr>
-          <p:cNvPr id="7" name="TextBox 6"/>
-          <p:cNvSpPr txBox="1"/>
+          <p:cNvPr id="7" name="Rectangle 6"/>
+          <p:cNvSpPr/>
           <p:nvPr/>
         </p:nvSpPr>
         <p:spPr>
           <a:xfrm>
-            <a:off x="713232" y="5440680"/>
-            <a:ext cx="10789920" cy="1005840"/>
+            <a:off x="713232" y="5943600"/>
+            <a:ext cx="10765231" cy="502920"/>
           </a:xfrm>
           <a:prstGeom prst="rect">
             <a:avLst/>
           </a:prstGeom>
-          <a:noFill/>
+          <a:solidFill>
+            <a:srgbClr val="F4F7FC"/>
+          </a:solidFill>
+          <a:ln w="9525">
+            <a:solidFill>
+              <a:srgbClr val="2A78D6"/>
+            </a:solidFill>
+          </a:ln>
+          <a:effectLst/>
         </p:spPr>
-        <p:txBody>
-          <a:bodyPr wrap="square">
-            <a:spAutoFit/>
-          </a:bodyPr>
+        <p:style>
+          <a:lnRef idx="1">
+            <a:schemeClr val="accent1"/>
+          </a:lnRef>
+          <a:fillRef idx="3">
+            <a:schemeClr val="accent1"/>
+          </a:fillRef>
+          <a:effectRef idx="2">
+            <a:schemeClr val="accent1"/>
+          </a:effectRef>
+          <a:fontRef idx="minor">
+            <a:schemeClr val="lt1"/>
+          </a:fontRef>
+        </p:style>
+        <p:txBody>
+          <a:bodyPr rtlCol="0" anchor="ctr" wrap="square" lIns="201168" rIns="201168" tIns="128016" bIns="128016"/>
           <a:lstStyle/>
           <a:p>
-            <a:pPr>
+            <a:pPr algn="ctr">
               <a:lnSpc>
                 <a:spcPct val="130000"/>
               </a:lnSpc>
               <a:spcAft>
-                <a:spcPts val="700"/>
+                <a:spcPts val="200"/>
               </a:spcAft>
             </a:pPr>
             <a:r>
-              <a:rPr sz="1400" b="0">
-                <a:solidFill>
-                  <a:srgbClr val="2F2E2B"/>
-                </a:solidFill>
-                <a:latin typeface="Helvetica Neue"/>
-              </a:rPr>
-              <a:t>Qwen2-Audio scores </a:t>
-            </a:r>
-            <a:r>
-              <a:rPr sz="1400" b="1">
+              <a:rPr sz="1250" b="0">
+                <a:solidFill>
+                  <a:srgbClr val="52514E"/>
+                </a:solidFill>
+                <a:latin typeface="Helvetica Neue"/>
+              </a:rPr>
+              <a:t>Three layers. </a:t>
+            </a:r>
+            <a:r>
+              <a:rPr sz="1250" b="1">
                 <a:solidFill>
                   <a:srgbClr val="0B0B0B"/>
                 </a:solidFill>
                 <a:latin typeface="Helvetica Neue"/>
               </a:rPr>
-              <a:t>0.094</a:t>
-            </a:r>
-            <a:r>
-              <a:rPr sz="1400" b="0">
-                <a:solidFill>
-                  <a:srgbClr val="2F2E2B"/>
-                </a:solidFill>
-                <a:latin typeface="Helvetica Neue"/>
-              </a:rPr>
-              <a:t> on plain grounding and </a:t>
-            </a:r>
-            <a:r>
-              <a:rPr sz="1400" b="1">
+              <a:t>Build</a:t>
+            </a:r>
+            <a:r>
+              <a:rPr sz="1250" b="0">
+                <a:solidFill>
+                  <a:srgbClr val="52514E"/>
+                </a:solidFill>
+                <a:latin typeface="Helvetica Neue"/>
+              </a:rPr>
+              <a:t> makes the audio and therefore knows the answer. </a:t>
+            </a:r>
+            <a:r>
+              <a:rPr sz="1250" b="1">
                 <a:solidFill>
                   <a:srgbClr val="0B0B0B"/>
                 </a:solidFill>
                 <a:latin typeface="Helvetica Neue"/>
               </a:rPr>
-              <a:t>exactly 0.000</a:t>
-            </a:r>
-            <a:r>
-              <a:rPr sz="1400" b="0">
-                <a:solidFill>
-                  <a:srgbClr val="2F2E2B"/>
-                </a:solidFill>
-                <a:latin typeface="Helvetica Neue"/>
-              </a:rPr>
-              <a:t> on every conditional type — it emits well-formed intervals that land nowhere near the event. SpotSound (2604.13023, §4.1) reports the same failure mode: “syntactically complete time windows … resulting in zero overlap with the ground truth.”</a:t>
-            </a:r>
-          </a:p>
-          <a:p>
-            <a:pPr>
-              <a:lnSpc>
-                <a:spcPct val="130000"/>
-              </a:lnSpc>
-              <a:spcAft>
-                <a:spcPts val="700"/>
-              </a:spcAft>
-            </a:pPr>
-            <a:r>
-              <a:rPr sz="1400" b="1">
+              <a:t>Answer</a:t>
+            </a:r>
+            <a:r>
+              <a:rPr sz="1250" b="0">
+                <a:solidFill>
+                  <a:srgbClr val="52514E"/>
+                </a:solidFill>
+                <a:latin typeface="Helvetica Neue"/>
+              </a:rPr>
+              <a:t> is five arms from one codebase. </a:t>
+            </a:r>
+            <a:r>
+              <a:rPr sz="1250" b="1">
                 <a:solidFill>
                   <a:srgbClr val="0B0B0B"/>
                 </a:solidFill>
                 <a:latin typeface="Helvetica Neue"/>
               </a:rPr>
-              <a:t>Qwen2.5-Omni is the backbone.</a:t>
-            </a:r>
-            <a:r>
-              <a:rPr sz="1400" b="0">
-                <a:solidFill>
-                  <a:srgbClr val="2F2E2B"/>
-                </a:solidFill>
-                <a:latin typeface="Helvetica Neue"/>
-              </a:rPr>
-              <a:t> It finds the sound, then drops the qualifier attached to it.</a:t>
+              <a:t>Score</a:t>
+            </a:r>
+            <a:r>
+              <a:rPr sz="1250" b="0">
+                <a:solidFill>
+                  <a:srgbClr val="52514E"/>
+                </a:solidFill>
+                <a:latin typeface="Helvetica Neue"/>
+              </a:rPr>
+              <a:t> is one metrics module, so every arm is measured the same way.</a:t>
             </a:r>
           </a:p>
         </p:txBody>
@@ -13906,7 +14702,7 @@
                 </a:solidFill>
                 <a:latin typeface="Helvetica Neue"/>
               </a:rPr>
-              <a:t>The hard part is not “conditions” — it is relating two events</a:t>
+              <a:t>Only one of the two candidate backbones can ground at all</a:t>
             </a:r>
           </a:p>
         </p:txBody>
@@ -13990,227 +14786,30 @@
           </a:p>
         </p:txBody>
       </p:sp>
-      <p:graphicFrame>
-        <p:nvGraphicFramePr>
-          <p:cNvPr id="6" name="Table 5"/>
-          <p:cNvGraphicFramePr>
-            <a:graphicFrameLocks noGrp="1"/>
-          </p:cNvGraphicFramePr>
+      <p:pic>
+        <p:nvPicPr>
+          <p:cNvPr id="6" name="Picture 5" descr="fig1_backbone.png"/>
+          <p:cNvPicPr>
+            <a:picLocks noChangeAspect="1"/>
+          </p:cNvPicPr>
           <p:nvPr/>
-        </p:nvGraphicFramePr>
-        <p:xfrm>
-          <a:off x="713232" y="1965960"/>
-          <a:ext cx="10765229" cy="1124712"/>
-        </p:xfrm>
-        <a:graphic>
-          <a:graphicData uri="http://schemas.openxmlformats.org/drawingml/2006/table">
-            <a:tbl>
-              <a:tblPr firstRow="1">
-                <a:tableStyleId>{5C22544A-7EE6-4342-B048-85BDC9FD1C3A}</a:tableStyleId>
-              </a:tblPr>
-              <a:tblGrid>
-                <a:gridCol w="2554461"/>
-                <a:gridCol w="4014153"/>
-                <a:gridCol w="4196615"/>
-              </a:tblGrid>
-              <a:tr h="347472">
-                <a:tc>
-                  <a:txBody>
-                    <a:bodyPr/>
-                    <a:lstStyle/>
-                    <a:p>
-                      <a:pPr algn="l">
-                        <a:lnSpc>
-                          <a:spcPct val="112000"/>
-                        </a:lnSpc>
-                        <a:spcAft>
-                          <a:spcPts val="100"/>
-                        </a:spcAft>
-                      </a:pPr>
-                    </a:p>
-                  </a:txBody>
-                  <a:tcPr marL="73152" marR="73152" marT="18288" marB="18288" anchor="ctr">
-                    <a:solidFill>
-                      <a:srgbClr val="F4F7FC"/>
-                    </a:solidFill>
-                  </a:tcPr>
-                </a:tc>
-                <a:tc>
-                  <a:txBody>
-                    <a:bodyPr/>
-                    <a:lstStyle/>
-                    <a:p>
-                      <a:pPr algn="ctr">
-                        <a:lnSpc>
-                          <a:spcPct val="112000"/>
-                        </a:lnSpc>
-                        <a:spcAft>
-                          <a:spcPts val="100"/>
-                        </a:spcAft>
-                      </a:pPr>
-                      <a:r>
-                        <a:rPr sz="1200" b="1">
-                          <a:solidFill>
-                            <a:srgbClr val="52514E"/>
-                          </a:solidFill>
-                          <a:latin typeface="Helvetica Neue"/>
-                        </a:rPr>
-                        <a:t>Handled</a:t>
-                      </a:r>
-                    </a:p>
-                  </a:txBody>
-                  <a:tcPr marL="73152" marR="73152" marT="18288" marB="18288" anchor="ctr">
-                    <a:solidFill>
-                      <a:srgbClr val="F4F7FC"/>
-                    </a:solidFill>
-                  </a:tcPr>
-                </a:tc>
-                <a:tc>
-                  <a:txBody>
-                    <a:bodyPr/>
-                    <a:lstStyle/>
-                    <a:p>
-                      <a:pPr algn="ctr">
-                        <a:lnSpc>
-                          <a:spcPct val="112000"/>
-                        </a:lnSpc>
-                        <a:spcAft>
-                          <a:spcPts val="100"/>
-                        </a:spcAft>
-                      </a:pPr>
-                      <a:r>
-                        <a:rPr sz="1200" b="1">
-                          <a:solidFill>
-                            <a:srgbClr val="52514E"/>
-                          </a:solidFill>
-                          <a:latin typeface="Helvetica Neue"/>
-                        </a:rPr>
-                        <a:t>Collapses</a:t>
-                      </a:r>
-                    </a:p>
-                  </a:txBody>
-                  <a:tcPr marL="73152" marR="73152" marT="18288" marB="18288" anchor="ctr">
-                    <a:solidFill>
-                      <a:srgbClr val="F4F7FC"/>
-                    </a:solidFill>
-                  </a:tcPr>
-                </a:tc>
-              </a:tr>
-              <a:tr h="777240">
-                <a:tc>
-                  <a:txBody>
-                    <a:bodyPr/>
-                    <a:lstStyle/>
-                    <a:p>
-                      <a:pPr algn="l">
-                        <a:lnSpc>
-                          <a:spcPct val="112000"/>
-                        </a:lnSpc>
-                        <a:spcAft>
-                          <a:spcPts val="100"/>
-                        </a:spcAft>
-                      </a:pPr>
-                      <a:r>
-                        <a:rPr sz="1300" b="0">
-                          <a:solidFill>
-                            <a:srgbClr val="2F2E2B"/>
-                          </a:solidFill>
-                          <a:latin typeface="Helvetica Neue"/>
-                        </a:rPr>
-                        <a:t>Qwen2.5-Omni, f1@0.5</a:t>
-                      </a:r>
-                    </a:p>
-                  </a:txBody>
-                  <a:tcPr marL="73152" marR="73152" marT="18288" marB="18288" anchor="ctr">
-                    <a:solidFill>
-                      <a:srgbClr val="FFFFFF"/>
-                    </a:solidFill>
-                  </a:tcPr>
-                </a:tc>
-                <a:tc>
-                  <a:txBody>
-                    <a:bodyPr/>
-                    <a:lstStyle/>
-                    <a:p>
-                      <a:pPr algn="ctr">
-                        <a:lnSpc>
-                          <a:spcPct val="112000"/>
-                        </a:lnSpc>
-                        <a:spcAft>
-                          <a:spcPts val="100"/>
-                        </a:spcAft>
-                      </a:pPr>
-                      <a:r>
-                        <a:rPr sz="1300" b="0">
-                          <a:solidFill>
-                            <a:srgbClr val="2F2E2B"/>
-                          </a:solidFill>
-                          <a:latin typeface="Helvetica Neue"/>
-                        </a:rPr>
-                        <a:t>BEFORE 0.379    ORDINAL 0.333</a:t>
-                      </a:r>
-                    </a:p>
-                  </a:txBody>
-                  <a:tcPr marL="73152" marR="73152" marT="18288" marB="18288" anchor="ctr">
-                    <a:solidFill>
-                      <a:srgbClr val="FFFFFF"/>
-                    </a:solidFill>
-                  </a:tcPr>
-                </a:tc>
-                <a:tc>
-                  <a:txBody>
-                    <a:bodyPr/>
-                    <a:lstStyle/>
-                    <a:p>
-                      <a:pPr algn="ctr">
-                        <a:lnSpc>
-                          <a:spcPct val="112000"/>
-                        </a:lnSpc>
-                        <a:spcAft>
-                          <a:spcPts val="100"/>
-                        </a:spcAft>
-                      </a:pPr>
-                      <a:r>
-                        <a:rPr sz="1300" b="0">
-                          <a:solidFill>
-                            <a:srgbClr val="2F2E2B"/>
-                          </a:solidFill>
-                          <a:latin typeface="Helvetica Neue"/>
-                        </a:rPr>
-                        <a:t>WHILE 0.152    AFTER 0.146</a:t>
-                      </a:r>
-                    </a:p>
-                    <a:p>
-                      <a:pPr algn="ctr">
-                        <a:lnSpc>
-                          <a:spcPct val="112000"/>
-                        </a:lnSpc>
-                        <a:spcAft>
-                          <a:spcPts val="100"/>
-                        </a:spcAft>
-                      </a:pPr>
-                      <a:r>
-                        <a:rPr sz="1300" b="0">
-                          <a:solidFill>
-                            <a:srgbClr val="2F2E2B"/>
-                          </a:solidFill>
-                          <a:latin typeface="Helvetica Neue"/>
-                        </a:rPr>
-                        <a:t>NOT_FOLLOWED 0.095    NEXT_AFTER 0.091</a:t>
-                      </a:r>
-                    </a:p>
-                  </a:txBody>
-                  <a:tcPr marL="73152" marR="73152" marT="18288" marB="18288" anchor="ctr">
-                    <a:solidFill>
-                      <a:srgbClr val="FFFFFF"/>
-                    </a:solidFill>
-                  </a:tcPr>
-                </a:tc>
-              </a:tr>
-            </a:tbl>
-          </a:graphicData>
-        </a:graphic>
-      </p:graphicFrame>
+        </p:nvPicPr>
+        <p:blipFill>
+          <a:blip r:embed="rId2"/>
+          <a:stretch>
+            <a:fillRect/>
+          </a:stretch>
+        </p:blipFill>
+        <p:spPr>
+          <a:xfrm>
+            <a:off x="1766031" y="1828800"/>
+            <a:ext cx="8659632" cy="3383280"/>
+          </a:xfrm>
+          <a:prstGeom prst="rect">
+            <a:avLst/>
+          </a:prstGeom>
+        </p:spPr>
+      </p:pic>
       <p:sp>
         <p:nvSpPr>
           <p:cNvPr id="7" name="TextBox 6"/>
@@ -14219,8 +14818,8 @@
         </p:nvSpPr>
         <p:spPr>
           <a:xfrm>
-            <a:off x="713232" y="3246120"/>
-            <a:ext cx="10789920" cy="2011680"/>
+            <a:off x="713232" y="5440680"/>
+            <a:ext cx="10789920" cy="1005840"/>
           </a:xfrm>
           <a:prstGeom prst="rect">
             <a:avLst/>
@@ -14238,17 +14837,53 @@
                 <a:spcPct val="130000"/>
               </a:lnSpc>
               <a:spcAft>
-                <a:spcPts val="1300"/>
+                <a:spcPts val="700"/>
               </a:spcAft>
             </a:pPr>
             <a:r>
-              <a:rPr sz="1600" b="0">
+              <a:rPr sz="1400" b="0">
                 <a:solidFill>
                   <a:srgbClr val="2F2E2B"/>
                 </a:solidFill>
                 <a:latin typeface="Helvetica Neue"/>
               </a:rPr>
-              <a:t>ORDINAL needs only counting inside one event type. BEFORE needs one comparison against a single reference.</a:t>
+              <a:t>Qwen2-Audio scores </a:t>
+            </a:r>
+            <a:r>
+              <a:rPr sz="1400" b="1">
+                <a:solidFill>
+                  <a:srgbClr val="0B0B0B"/>
+                </a:solidFill>
+                <a:latin typeface="Helvetica Neue"/>
+              </a:rPr>
+              <a:t>0.094</a:t>
+            </a:r>
+            <a:r>
+              <a:rPr sz="1400" b="0">
+                <a:solidFill>
+                  <a:srgbClr val="2F2E2B"/>
+                </a:solidFill>
+                <a:latin typeface="Helvetica Neue"/>
+              </a:rPr>
+              <a:t> on plain grounding and </a:t>
+            </a:r>
+            <a:r>
+              <a:rPr sz="1400" b="1">
+                <a:solidFill>
+                  <a:srgbClr val="0B0B0B"/>
+                </a:solidFill>
+                <a:latin typeface="Helvetica Neue"/>
+              </a:rPr>
+              <a:t>exactly 0.000</a:t>
+            </a:r>
+            <a:r>
+              <a:rPr sz="1400" b="0">
+                <a:solidFill>
+                  <a:srgbClr val="2F2E2B"/>
+                </a:solidFill>
+                <a:latin typeface="Helvetica Neue"/>
+              </a:rPr>
+              <a:t> on every conditional type — it emits well-formed intervals that land nowhere near the event. SpotSound (2604.13023, §4.1) reports the same failure mode: “syntactically complete time windows … resulting in zero overlap with the ground truth.”</a:t>
             </a:r>
           </a:p>
           <a:p>
@@ -14257,72 +14892,26 @@
                 <a:spcPct val="130000"/>
               </a:lnSpc>
               <a:spcAft>
-                <a:spcPts val="1300"/>
+                <a:spcPts val="700"/>
               </a:spcAft>
             </a:pPr>
             <a:r>
-              <a:rPr sz="1600" b="0">
+              <a:rPr sz="1400" b="1">
+                <a:solidFill>
+                  <a:srgbClr val="0B0B0B"/>
+                </a:solidFill>
+                <a:latin typeface="Helvetica Neue"/>
+              </a:rPr>
+              <a:t>Qwen2.5-Omni is the backbone.</a:t>
+            </a:r>
+            <a:r>
+              <a:rPr sz="1400" b="0">
                 <a:solidFill>
                   <a:srgbClr val="2F2E2B"/>
                 </a:solidFill>
                 <a:latin typeface="Helvetica Neue"/>
               </a:rPr>
-              <a:t>The four that collapse all require </a:t>
-            </a:r>
-            <a:r>
-              <a:rPr sz="1600" b="1">
-                <a:solidFill>
-                  <a:srgbClr val="0B0B0B"/>
-                </a:solidFill>
-                <a:latin typeface="Helvetica Neue"/>
-              </a:rPr>
-              <a:t>relating the target to a second event and then selecting among the matches</a:t>
-            </a:r>
-            <a:r>
-              <a:rPr sz="1600" b="0">
-                <a:solidFill>
-                  <a:srgbClr val="2F2E2B"/>
-                </a:solidFill>
-                <a:latin typeface="Helvetica Neue"/>
-              </a:rPr>
-              <a:t>. That is the specific capability that is missing.</a:t>
-            </a:r>
-          </a:p>
-          <a:p>
-            <a:pPr>
-              <a:lnSpc>
-                <a:spcPct val="130000"/>
-              </a:lnSpc>
-              <a:spcAft>
-                <a:spcPts val="1300"/>
-              </a:spcAft>
-            </a:pPr>
-            <a:r>
-              <a:rPr sz="1600" b="0">
-                <a:solidFill>
-                  <a:srgbClr val="2F2E2B"/>
-                </a:solidFill>
-                <a:latin typeface="Helvetica Neue"/>
-              </a:rPr>
-              <a:t>Supporting signal: on NOT_FOLLOWED the model under-reports on </a:t>
-            </a:r>
-            <a:r>
-              <a:rPr sz="1600" b="1">
-                <a:solidFill>
-                  <a:srgbClr val="0B0B0B"/>
-                </a:solidFill>
-                <a:latin typeface="Helvetica Neue"/>
-              </a:rPr>
-              <a:t>69%</a:t>
-            </a:r>
-            <a:r>
-              <a:rPr sz="1600" b="0">
-                <a:solidFill>
-                  <a:srgbClr val="2F2E2B"/>
-                </a:solidFill>
-                <a:latin typeface="Helvetica Neue"/>
-              </a:rPr>
-              <a:t> of queries — the highest of any type — consistent with collapsing a set of matches down to one.</a:t>
+              <a:t> It finds the sound, then drops the qualifier attached to it.</a:t>
             </a:r>
           </a:p>
         </p:txBody>
@@ -14374,7 +14963,7 @@
                 </a:solidFill>
                 <a:latin typeface="Helvetica Neue"/>
               </a:rPr>
-              <a:t>THE DIAGNOSTIC</a:t>
+              <a:t>PHASE 1</a:t>
             </a:r>
           </a:p>
         </p:txBody>
@@ -14408,7 +14997,7 @@
                 </a:solidFill>
                 <a:latin typeface="Helvetica Neue"/>
               </a:rPr>
-              <a:t>Is the model bad at conditions, or bad at hearing?</a:t>
+              <a:t>The hard part is not “conditions” — it is relating two events</a:t>
             </a:r>
           </a:p>
         </p:txBody>
@@ -14492,77 +15081,17 @@
           </a:p>
         </p:txBody>
       </p:sp>
-      <p:sp>
-        <p:nvSpPr>
-          <p:cNvPr id="6" name="TextBox 5"/>
-          <p:cNvSpPr txBox="1"/>
-          <p:nvPr/>
-        </p:nvSpPr>
-        <p:spPr>
-          <a:xfrm>
-            <a:off x="713232" y="1828800"/>
-            <a:ext cx="10789920" cy="548640"/>
-          </a:xfrm>
-          <a:prstGeom prst="rect">
-            <a:avLst/>
-          </a:prstGeom>
-          <a:noFill/>
-        </p:spPr>
-        <p:txBody>
-          <a:bodyPr wrap="square">
-            <a:spAutoFit/>
-          </a:bodyPr>
-          <a:lstStyle/>
-          <a:p>
-            <a:pPr>
-              <a:lnSpc>
-                <a:spcPct val="130000"/>
-              </a:lnSpc>
-              <a:spcAft>
-                <a:spcPts val="600"/>
-              </a:spcAft>
-            </a:pPr>
-            <a:r>
-              <a:rPr sz="1500" b="0">
-                <a:solidFill>
-                  <a:srgbClr val="52514E"/>
-                </a:solidFill>
-                <a:latin typeface="Helvetica Neue"/>
-              </a:rPr>
-              <a:t>Answer the condition </a:t>
-            </a:r>
-            <a:r>
-              <a:rPr sz="1500" b="1">
-                <a:solidFill>
-                  <a:srgbClr val="0B0B0B"/>
-                </a:solidFill>
-                <a:latin typeface="Helvetica Neue"/>
-              </a:rPr>
-              <a:t>for</a:t>
-            </a:r>
-            <a:r>
-              <a:rPr sz="1500" b="0">
-                <a:solidFill>
-                  <a:srgbClr val="52514E"/>
-                </a:solidFill>
-                <a:latin typeface="Helvetica Neue"/>
-              </a:rPr>
-              <a:t> the model: ground each sound separately, then apply the condition with the same predicates that define the ground truth. Then degrade the grounder on purpose.</a:t>
-            </a:r>
-          </a:p>
-        </p:txBody>
-      </p:sp>
       <p:graphicFrame>
         <p:nvGraphicFramePr>
-          <p:cNvPr id="7" name="Table 6"/>
+          <p:cNvPr id="6" name="Table 5"/>
           <p:cNvGraphicFramePr>
             <a:graphicFrameLocks noGrp="1"/>
           </p:cNvGraphicFramePr>
           <p:nvPr/>
         </p:nvGraphicFramePr>
         <p:xfrm>
-          <a:off x="713232" y="2651760"/>
-          <a:ext cx="7498078" cy="2651760"/>
+          <a:off x="713232" y="1965960"/>
+          <a:ext cx="10765229" cy="1124712"/>
         </p:xfrm>
         <a:graphic>
           <a:graphicData uri="http://schemas.openxmlformats.org/drawingml/2006/table">
@@ -14571,8 +15100,9 @@
                 <a:tableStyleId>{5C22544A-7EE6-4342-B048-85BDC9FD1C3A}</a:tableStyleId>
               </a:tblPr>
               <a:tblGrid>
-                <a:gridCol w="5120639"/>
-                <a:gridCol w="2377439"/>
+                <a:gridCol w="2554461"/>
+                <a:gridCol w="4014153"/>
+                <a:gridCol w="4196615"/>
               </a:tblGrid>
               <a:tr h="347472">
                 <a:tc>
@@ -14588,6 +15118,27 @@
                           <a:spcPts val="100"/>
                         </a:spcAft>
                       </a:pPr>
+                    </a:p>
+                  </a:txBody>
+                  <a:tcPr marL="73152" marR="73152" marT="18288" marB="18288" anchor="ctr">
+                    <a:solidFill>
+                      <a:srgbClr val="F4F7FC"/>
+                    </a:solidFill>
+                  </a:tcPr>
+                </a:tc>
+                <a:tc>
+                  <a:txBody>
+                    <a:bodyPr/>
+                    <a:lstStyle/>
+                    <a:p>
+                      <a:pPr algn="ctr">
+                        <a:lnSpc>
+                          <a:spcPct val="112000"/>
+                        </a:lnSpc>
+                        <a:spcAft>
+                          <a:spcPts val="100"/>
+                        </a:spcAft>
+                      </a:pPr>
                       <a:r>
                         <a:rPr sz="1200" b="1">
                           <a:solidFill>
@@ -14595,7 +15146,7 @@
                           </a:solidFill>
                           <a:latin typeface="Helvetica Neue"/>
                         </a:rPr>
-                        <a:t>Grounding quality given to the composer</a:t>
+                        <a:t>Handled</a:t>
                       </a:r>
                     </a:p>
                   </a:txBody>
@@ -14625,7 +15176,7 @@
                           </a:solidFill>
                           <a:latin typeface="Helvetica Neue"/>
                         </a:rPr>
-                        <a:t>f1@0.5, all 4404 queries</a:t>
+                        <a:t>Collapses</a:t>
                       </a:r>
                     </a:p>
                   </a:txBody>
@@ -14636,7 +15187,7 @@
                   </a:tcPr>
                 </a:tc>
               </a:tr>
-              <a:tr h="384048">
+              <a:tr h="777240">
                 <a:tc>
                   <a:txBody>
                     <a:bodyPr/>
@@ -14651,13 +15202,13 @@
                         </a:spcAft>
                       </a:pPr>
                       <a:r>
-                        <a:rPr sz="1350" b="0">
-                          <a:solidFill>
-                            <a:srgbClr val="2F2E2B"/>
-                          </a:solidFill>
-                          <a:latin typeface="Helvetica Neue"/>
-                        </a:rPr>
-                        <a:t>Perfect</a:t>
+                        <a:rPr sz="1300" b="0">
+                          <a:solidFill>
+                            <a:srgbClr val="2F2E2B"/>
+                          </a:solidFill>
+                          <a:latin typeface="Helvetica Neue"/>
+                        </a:rPr>
+                        <a:t>Qwen2.5-Omni, f1@0.5</a:t>
                       </a:r>
                     </a:p>
                   </a:txBody>
@@ -14681,45 +15232,13 @@
                         </a:spcAft>
                       </a:pPr>
                       <a:r>
-                        <a:rPr sz="1350" b="0">
-                          <a:solidFill>
-                            <a:srgbClr val="2F2E2B"/>
-                          </a:solidFill>
-                          <a:latin typeface="Helvetica Neue"/>
-                        </a:rPr>
-                        <a:t>1.000</a:t>
-                      </a:r>
-                    </a:p>
-                  </a:txBody>
-                  <a:tcPr marL="73152" marR="73152" marT="18288" marB="18288" anchor="ctr">
-                    <a:solidFill>
-                      <a:srgbClr val="FFFFFF"/>
-                    </a:solidFill>
-                  </a:tcPr>
-                </a:tc>
-              </a:tr>
-              <a:tr h="384048">
-                <a:tc>
-                  <a:txBody>
-                    <a:bodyPr/>
-                    <a:lstStyle/>
-                    <a:p>
-                      <a:pPr algn="l">
-                        <a:lnSpc>
-                          <a:spcPct val="112000"/>
-                        </a:lnSpc>
-                        <a:spcAft>
-                          <a:spcPts val="100"/>
-                        </a:spcAft>
-                      </a:pPr>
-                      <a:r>
-                        <a:rPr sz="1350" b="0">
-                          <a:solidFill>
-                            <a:srgbClr val="2F2E2B"/>
-                          </a:solidFill>
-                          <a:latin typeface="Helvetica Neue"/>
-                        </a:rPr>
-                        <a:t>Boundaries jittered ±0.5 s</a:t>
+                        <a:rPr sz="1300" b="0">
+                          <a:solidFill>
+                            <a:srgbClr val="2F2E2B"/>
+                          </a:solidFill>
+                          <a:latin typeface="Helvetica Neue"/>
+                        </a:rPr>
+                        <a:t>BEFORE 0.379    ORDINAL 0.333</a:t>
                       </a:r>
                     </a:p>
                   </a:txBody>
@@ -14743,58 +15262,15 @@
                         </a:spcAft>
                       </a:pPr>
                       <a:r>
-                        <a:rPr sz="1350" b="0">
-                          <a:solidFill>
-                            <a:srgbClr val="2F2E2B"/>
-                          </a:solidFill>
-                          <a:latin typeface="Helvetica Neue"/>
-                        </a:rPr>
-                        <a:t>0.925</a:t>
-                      </a:r>
-                    </a:p>
-                  </a:txBody>
-                  <a:tcPr marL="73152" marR="73152" marT="18288" marB="18288" anchor="ctr">
-                    <a:solidFill>
-                      <a:srgbClr val="FFFFFF"/>
-                    </a:solidFill>
-                  </a:tcPr>
-                </a:tc>
-              </a:tr>
-              <a:tr h="384048">
-                <a:tc>
-                  <a:txBody>
-                    <a:bodyPr/>
-                    <a:lstStyle/>
-                    <a:p>
-                      <a:pPr algn="l">
-                        <a:lnSpc>
-                          <a:spcPct val="112000"/>
-                        </a:lnSpc>
-                        <a:spcAft>
-                          <a:spcPts val="100"/>
-                        </a:spcAft>
-                      </a:pPr>
-                      <a:r>
-                        <a:rPr sz="1350" b="0">
-                          <a:solidFill>
-                            <a:srgbClr val="2F2E2B"/>
-                          </a:solidFill>
-                          <a:latin typeface="Helvetica Neue"/>
-                        </a:rPr>
-                        <a:t>25% of events missed</a:t>
-                      </a:r>
-                    </a:p>
-                  </a:txBody>
-                  <a:tcPr marL="73152" marR="73152" marT="18288" marB="18288" anchor="ctr">
-                    <a:solidFill>
-                      <a:srgbClr val="FFFFFF"/>
-                    </a:solidFill>
-                  </a:tcPr>
-                </a:tc>
-                <a:tc>
-                  <a:txBody>
-                    <a:bodyPr/>
-                    <a:lstStyle/>
+                        <a:rPr sz="1300" b="0">
+                          <a:solidFill>
+                            <a:srgbClr val="2F2E2B"/>
+                          </a:solidFill>
+                          <a:latin typeface="Helvetica Neue"/>
+                        </a:rPr>
+                        <a:t>WHILE 0.152    AFTER 0.146</a:t>
+                      </a:r>
+                    </a:p>
                     <a:p>
                       <a:pPr algn="ctr">
                         <a:lnSpc>
@@ -14805,199 +15281,13 @@
                         </a:spcAft>
                       </a:pPr>
                       <a:r>
-                        <a:rPr sz="1350" b="0">
-                          <a:solidFill>
-                            <a:srgbClr val="2F2E2B"/>
-                          </a:solidFill>
-                          <a:latin typeface="Helvetica Neue"/>
-                        </a:rPr>
-                        <a:t>0.650</a:t>
-                      </a:r>
-                    </a:p>
-                  </a:txBody>
-                  <a:tcPr marL="73152" marR="73152" marT="18288" marB="18288" anchor="ctr">
-                    <a:solidFill>
-                      <a:srgbClr val="FFFFFF"/>
-                    </a:solidFill>
-                  </a:tcPr>
-                </a:tc>
-              </a:tr>
-              <a:tr h="384048">
-                <a:tc>
-                  <a:txBody>
-                    <a:bodyPr/>
-                    <a:lstStyle/>
-                    <a:p>
-                      <a:pPr algn="l">
-                        <a:lnSpc>
-                          <a:spcPct val="112000"/>
-                        </a:lnSpc>
-                        <a:spcAft>
-                          <a:spcPts val="100"/>
-                        </a:spcAft>
-                      </a:pPr>
-                      <a:r>
-                        <a:rPr sz="1350" b="0">
-                          <a:solidFill>
-                            <a:srgbClr val="2F2E2B"/>
-                          </a:solidFill>
-                          <a:latin typeface="Helvetica Neue"/>
-                        </a:rPr>
-                        <a:t>25% spurious detections</a:t>
-                      </a:r>
-                    </a:p>
-                  </a:txBody>
-                  <a:tcPr marL="73152" marR="73152" marT="18288" marB="18288" anchor="ctr">
-                    <a:solidFill>
-                      <a:srgbClr val="FFFFFF"/>
-                    </a:solidFill>
-                  </a:tcPr>
-                </a:tc>
-                <a:tc>
-                  <a:txBody>
-                    <a:bodyPr/>
-                    <a:lstStyle/>
-                    <a:p>
-                      <a:pPr algn="ctr">
-                        <a:lnSpc>
-                          <a:spcPct val="112000"/>
-                        </a:lnSpc>
-                        <a:spcAft>
-                          <a:spcPts val="100"/>
-                        </a:spcAft>
-                      </a:pPr>
-                      <a:r>
-                        <a:rPr sz="1350" b="0">
-                          <a:solidFill>
-                            <a:srgbClr val="2F2E2B"/>
-                          </a:solidFill>
-                          <a:latin typeface="Helvetica Neue"/>
-                        </a:rPr>
-                        <a:t>0.937</a:t>
-                      </a:r>
-                    </a:p>
-                  </a:txBody>
-                  <a:tcPr marL="73152" marR="73152" marT="18288" marB="18288" anchor="ctr">
-                    <a:solidFill>
-                      <a:srgbClr val="FFFFFF"/>
-                    </a:solidFill>
-                  </a:tcPr>
-                </a:tc>
-              </a:tr>
-              <a:tr h="384048">
-                <a:tc>
-                  <a:txBody>
-                    <a:bodyPr/>
-                    <a:lstStyle/>
-                    <a:p>
-                      <a:pPr algn="l">
-                        <a:lnSpc>
-                          <a:spcPct val="112000"/>
-                        </a:lnSpc>
-                        <a:spcAft>
-                          <a:spcPts val="100"/>
-                        </a:spcAft>
-                      </a:pPr>
-                      <a:r>
-                        <a:rPr sz="1350" b="0">
-                          <a:solidFill>
-                            <a:srgbClr val="2F2E2B"/>
-                          </a:solidFill>
-                          <a:latin typeface="Helvetica Neue"/>
-                        </a:rPr>
-                        <a:t>Degraded until PLAIN matches Qwen2.5-Omni</a:t>
-                      </a:r>
-                    </a:p>
-                  </a:txBody>
-                  <a:tcPr marL="73152" marR="73152" marT="18288" marB="18288" anchor="ctr">
-                    <a:solidFill>
-                      <a:srgbClr val="FFFFFF"/>
-                    </a:solidFill>
-                  </a:tcPr>
-                </a:tc>
-                <a:tc>
-                  <a:txBody>
-                    <a:bodyPr/>
-                    <a:lstStyle/>
-                    <a:p>
-                      <a:pPr algn="ctr">
-                        <a:lnSpc>
-                          <a:spcPct val="112000"/>
-                        </a:lnSpc>
-                        <a:spcAft>
-                          <a:spcPts val="100"/>
-                        </a:spcAft>
-                      </a:pPr>
-                      <a:r>
-                        <a:rPr sz="1350" b="1">
-                          <a:solidFill>
-                            <a:srgbClr val="2A78D6"/>
-                          </a:solidFill>
-                          <a:latin typeface="Helvetica Neue"/>
-                        </a:rPr>
-                        <a:t>0.263</a:t>
-                      </a:r>
-                    </a:p>
-                  </a:txBody>
-                  <a:tcPr marL="73152" marR="73152" marT="18288" marB="18288" anchor="ctr">
-                    <a:solidFill>
-                      <a:srgbClr val="FFFFFF"/>
-                    </a:solidFill>
-                  </a:tcPr>
-                </a:tc>
-              </a:tr>
-              <a:tr h="384048">
-                <a:tc>
-                  <a:txBody>
-                    <a:bodyPr/>
-                    <a:lstStyle/>
-                    <a:p>
-                      <a:pPr algn="l">
-                        <a:lnSpc>
-                          <a:spcPct val="112000"/>
-                        </a:lnSpc>
-                        <a:spcAft>
-                          <a:spcPts val="100"/>
-                        </a:spcAft>
-                      </a:pPr>
-                      <a:r>
-                        <a:rPr sz="1350" b="0">
-                          <a:solidFill>
-                            <a:srgbClr val="2F2E2B"/>
-                          </a:solidFill>
-                          <a:latin typeface="Helvetica Neue"/>
-                        </a:rPr>
-                        <a:t>Qwen2.5-Omni answering directly</a:t>
-                      </a:r>
-                    </a:p>
-                  </a:txBody>
-                  <a:tcPr marL="73152" marR="73152" marT="18288" marB="18288" anchor="ctr">
-                    <a:solidFill>
-                      <a:srgbClr val="FFFFFF"/>
-                    </a:solidFill>
-                  </a:tcPr>
-                </a:tc>
-                <a:tc>
-                  <a:txBody>
-                    <a:bodyPr/>
-                    <a:lstStyle/>
-                    <a:p>
-                      <a:pPr algn="ctr">
-                        <a:lnSpc>
-                          <a:spcPct val="112000"/>
-                        </a:lnSpc>
-                        <a:spcAft>
-                          <a:spcPts val="100"/>
-                        </a:spcAft>
-                      </a:pPr>
-                      <a:r>
-                        <a:rPr sz="1350" b="1">
-                          <a:solidFill>
-                            <a:srgbClr val="2A78D6"/>
-                          </a:solidFill>
-                          <a:latin typeface="Helvetica Neue"/>
-                        </a:rPr>
-                        <a:t>0.243</a:t>
+                        <a:rPr sz="1300" b="0">
+                          <a:solidFill>
+                            <a:srgbClr val="2F2E2B"/>
+                          </a:solidFill>
+                          <a:latin typeface="Helvetica Neue"/>
+                        </a:rPr>
+                        <a:t>NOT_FOLLOWED 0.095    NEXT_AFTER 0.091</a:t>
                       </a:r>
                     </a:p>
                   </a:txBody>
@@ -15014,100 +15304,116 @@
       </p:graphicFrame>
       <p:sp>
         <p:nvSpPr>
-          <p:cNvPr id="8" name="Rectangle 7"/>
-          <p:cNvSpPr/>
+          <p:cNvPr id="7" name="TextBox 6"/>
+          <p:cNvSpPr txBox="1"/>
           <p:nvPr/>
         </p:nvSpPr>
         <p:spPr>
           <a:xfrm>
-            <a:off x="8595360" y="2651760"/>
-            <a:ext cx="2880360" cy="2688336"/>
+            <a:off x="713232" y="3246120"/>
+            <a:ext cx="10789920" cy="2011680"/>
           </a:xfrm>
           <a:prstGeom prst="rect">
             <a:avLst/>
           </a:prstGeom>
-          <a:solidFill>
-            <a:srgbClr val="F4F7FC"/>
-          </a:solidFill>
-          <a:ln w="9525">
-            <a:solidFill>
-              <a:srgbClr val="2A78D6"/>
-            </a:solidFill>
-          </a:ln>
-          <a:effectLst/>
+          <a:noFill/>
         </p:spPr>
-        <p:style>
-          <a:lnRef idx="1">
-            <a:schemeClr val="accent1"/>
-          </a:lnRef>
-          <a:fillRef idx="3">
-            <a:schemeClr val="accent1"/>
-          </a:fillRef>
-          <a:effectRef idx="2">
-            <a:schemeClr val="accent1"/>
-          </a:effectRef>
-          <a:fontRef idx="minor">
-            <a:schemeClr val="lt1"/>
-          </a:fontRef>
-        </p:style>
-        <p:txBody>
-          <a:bodyPr rtlCol="0" anchor="ctr" wrap="square" lIns="201168" rIns="201168" tIns="128016" bIns="128016"/>
+        <p:txBody>
+          <a:bodyPr wrap="square">
+            <a:spAutoFit/>
+          </a:bodyPr>
           <a:lstStyle/>
           <a:p>
-            <a:pPr algn="ctr">
+            <a:pPr>
               <a:lnSpc>
                 <a:spcPct val="130000"/>
               </a:lnSpc>
               <a:spcAft>
-                <a:spcPts val="200"/>
+                <a:spcPts val="1300"/>
               </a:spcAft>
             </a:pPr>
             <a:r>
-              <a:rPr sz="1400" b="0">
-                <a:solidFill>
-                  <a:srgbClr val="52514E"/>
-                </a:solidFill>
-                <a:latin typeface="Helvetica Neue"/>
-              </a:rPr>
-              <a:t>Perfect events give </a:t>
-            </a:r>
-            <a:r>
-              <a:rPr sz="1400" b="1">
+              <a:rPr sz="1600" b="0">
+                <a:solidFill>
+                  <a:srgbClr val="2F2E2B"/>
+                </a:solidFill>
+                <a:latin typeface="Helvetica Neue"/>
+              </a:rPr>
+              <a:t>ORDINAL needs only counting inside one event type. BEFORE needs one comparison against a single reference.</a:t>
+            </a:r>
+          </a:p>
+          <a:p>
+            <a:pPr>
+              <a:lnSpc>
+                <a:spcPct val="130000"/>
+              </a:lnSpc>
+              <a:spcAft>
+                <a:spcPts val="1300"/>
+              </a:spcAft>
+            </a:pPr>
+            <a:r>
+              <a:rPr sz="1600" b="0">
+                <a:solidFill>
+                  <a:srgbClr val="2F2E2B"/>
+                </a:solidFill>
+                <a:latin typeface="Helvetica Neue"/>
+              </a:rPr>
+              <a:t>The four that collapse all require </a:t>
+            </a:r>
+            <a:r>
+              <a:rPr sz="1600" b="1">
                 <a:solidFill>
                   <a:srgbClr val="0B0B0B"/>
                 </a:solidFill>
                 <a:latin typeface="Helvetica Neue"/>
               </a:rPr>
-              <a:t>1.000</a:t>
-            </a:r>
-            <a:r>
-              <a:rPr sz="1400" b="0">
-                <a:solidFill>
-                  <a:srgbClr val="52514E"/>
-                </a:solidFill>
-                <a:latin typeface="Helvetica Neue"/>
-              </a:rPr>
-              <a:t> on every condition type.
-So the conditions are trivial.
-</a:t>
-            </a:r>
-            <a:r>
-              <a:rPr sz="1400" b="1">
+              <a:t>relating the target to a second event and then selecting among the matches</a:t>
+            </a:r>
+            <a:r>
+              <a:rPr sz="1600" b="0">
+                <a:solidFill>
+                  <a:srgbClr val="2F2E2B"/>
+                </a:solidFill>
+                <a:latin typeface="Helvetica Neue"/>
+              </a:rPr>
+              <a:t>. That is the specific capability that is missing.</a:t>
+            </a:r>
+          </a:p>
+          <a:p>
+            <a:pPr>
+              <a:lnSpc>
+                <a:spcPct val="130000"/>
+              </a:lnSpc>
+              <a:spcAft>
+                <a:spcPts val="1300"/>
+              </a:spcAft>
+            </a:pPr>
+            <a:r>
+              <a:rPr sz="1600" b="0">
+                <a:solidFill>
+                  <a:srgbClr val="2F2E2B"/>
+                </a:solidFill>
+                <a:latin typeface="Helvetica Neue"/>
+              </a:rPr>
+              <a:t>Supporting signal: on NOT_FOLLOWED the model under-reports on </a:t>
+            </a:r>
+            <a:r>
+              <a:rPr sz="1600" b="1">
                 <a:solidFill>
                   <a:srgbClr val="0B0B0B"/>
                 </a:solidFill>
                 <a:latin typeface="Helvetica Neue"/>
               </a:rPr>
-              <a:t>Grounding quality is the binding constraint</a:t>
-            </a:r>
-            <a:r>
-              <a:rPr sz="1400" b="0">
-                <a:solidFill>
-                  <a:srgbClr val="52514E"/>
-                </a:solidFill>
-                <a:latin typeface="Helvetica Neue"/>
-              </a:rPr>
-              <a:t> — essentially the whole gap from 1.000 to 0.26.</a:t>
+              <a:t>69%</a:t>
+            </a:r>
+            <a:r>
+              <a:rPr sz="1600" b="0">
+                <a:solidFill>
+                  <a:srgbClr val="2F2E2B"/>
+                </a:solidFill>
+                <a:latin typeface="Helvetica Neue"/>
+              </a:rPr>
+              <a:t> of queries — the highest of any type — consistent with collapsing a set of matches down to one.</a:t>
             </a:r>
           </a:p>
         </p:txBody>

</xml_diff>